<commit_message>
docs: fix report and deck visual layout
</commit_message>
<xml_diff>
--- a/output/ppt/fci_plus_star_advisor_presentation.pptx
+++ b/output/ppt/fci_plus_star_advisor_presentation.pptx
@@ -2436,8 +2436,8 @@
           </p:nvSpPr>
           <p:spPr>
             <a:xfrm>
-              <a:off x="10787634" y="406718"/>
-              <a:ext cx="877824" cy="264033"/>
+              <a:off x="10480327" y="406718"/>
+              <a:ext cx="1185131" cy="264033"/>
             </a:xfrm>
             <a:prstGeom prst="rect">
               <a:avLst/>
@@ -2463,7 +2463,7 @@
                   <a:ea typeface="Consolas"/>
                   <a:cs typeface="Consolas"/>
                 </a:rPr>
-                <a:t>FCI / FCI+</a:t>
+                <a:t>FCI / FCI Plus</a:t>
               </a:r>
             </a:p>
           </p:txBody>
@@ -2492,7 +2492,7 @@
           <p:spPr>
             <a:xfrm>
               <a:off x="516636" y="901065"/>
-              <a:ext cx="6232495" cy="645414"/>
+              <a:ext cx="7109612" cy="645414"/>
             </a:xfrm>
             <a:prstGeom prst="rect">
               <a:avLst/>
@@ -2518,7 +2518,7 @@
                   <a:ea typeface="+mj-ea"/>
                   <a:cs typeface="+mj-cs"/>
                 </a:rPr>
-                <a:t>Independent FCI and FCI+</a:t>
+                <a:t>Independent FCI and FCI Plus</a:t>
               </a:r>
             </a:p>
           </p:txBody>
@@ -2843,20 +2843,20 @@
           </p:nvSpPr>
           <p:spPr>
             <a:xfrm>
-              <a:off x="831342" y="3464242"/>
-              <a:ext cx="1939237" cy="264033"/>
-            </a:xfrm>
-            <a:prstGeom prst="rect">
-              <a:avLst/>
-            </a:prstGeom>
-            <a:noFill/>
-            <a:ln>
-              <a:noFill/>
-            </a:ln>
-          </p:spPr>
-          <p:txBody>
-            <a:bodyPr wrap="none" lIns="0" tIns="0" rIns="0" bIns="0" anchor="t" anchorCtr="0">
-              <a:spAutoFit/>
+              <a:off x="838200" y="3390900"/>
+              <a:ext cx="2286000" cy="285750"/>
+            </a:xfrm>
+            <a:prstGeom prst="rect">
+              <a:avLst/>
+            </a:prstGeom>
+            <a:noFill/>
+            <a:ln>
+              <a:noFill/>
+            </a:ln>
+          </p:spPr>
+          <p:txBody>
+            <a:bodyPr wrap="square" lIns="0" tIns="73342" rIns="0" bIns="0" anchor="t" anchorCtr="0">
+              <a:noAutofit/>
             </a:bodyPr>
             <a:lstStyle/>
             <a:p>
@@ -3114,20 +3114,20 @@
           </p:nvSpPr>
           <p:spPr>
             <a:xfrm>
-              <a:off x="831342" y="4654868"/>
-              <a:ext cx="2070293" cy="264033"/>
-            </a:xfrm>
-            <a:prstGeom prst="rect">
-              <a:avLst/>
-            </a:prstGeom>
-            <a:noFill/>
-            <a:ln>
-              <a:noFill/>
-            </a:ln>
-          </p:spPr>
-          <p:txBody>
-            <a:bodyPr wrap="none" lIns="0" tIns="0" rIns="0" bIns="0" anchor="t" anchorCtr="0">
-              <a:spAutoFit/>
+              <a:off x="838200" y="4581525"/>
+              <a:ext cx="2381250" cy="285750"/>
+            </a:xfrm>
+            <a:prstGeom prst="rect">
+              <a:avLst/>
+            </a:prstGeom>
+            <a:noFill/>
+            <a:ln>
+              <a:noFill/>
+            </a:ln>
+          </p:spPr>
+          <p:txBody>
+            <a:bodyPr wrap="square" lIns="0" tIns="73342" rIns="0" bIns="0" anchor="t" anchorCtr="0">
+              <a:noAutofit/>
             </a:bodyPr>
             <a:lstStyle/>
             <a:p>
@@ -3359,26 +3359,26 @@
           </p:nvSpPr>
           <p:spPr>
             <a:xfrm>
-              <a:off x="8927592" y="3511868"/>
-              <a:ext cx="2112485" cy="264033"/>
-            </a:xfrm>
-            <a:prstGeom prst="rect">
-              <a:avLst/>
-            </a:prstGeom>
-            <a:noFill/>
-            <a:ln>
-              <a:noFill/>
-            </a:ln>
-          </p:spPr>
-          <p:txBody>
-            <a:bodyPr wrap="none" lIns="0" tIns="0" rIns="0" bIns="0" anchor="t" anchorCtr="0">
-              <a:spAutoFit/>
+              <a:off x="8934450" y="3438525"/>
+              <a:ext cx="2343150" cy="285750"/>
+            </a:xfrm>
+            <a:prstGeom prst="rect">
+              <a:avLst/>
+            </a:prstGeom>
+            <a:noFill/>
+            <a:ln>
+              <a:noFill/>
+            </a:ln>
+          </p:spPr>
+          <p:txBody>
+            <a:bodyPr wrap="square" lIns="0" tIns="73342" rIns="0" bIns="0" anchor="t" anchorCtr="0">
+              <a:noAutofit/>
             </a:bodyPr>
             <a:lstStyle/>
             <a:p>
               <a:pPr algn="l"/>
               <a:r>
-                <a:rPr lang="en-US" sz="1350" b="1" spc="105" dirty="0">
+                <a:rPr lang="en-US" sz="1350" b="1" spc="90" dirty="0">
                   <a:solidFill>
                     <a:srgbClr val="E9EDF5"/>
                   </a:solidFill>
@@ -4881,7 +4881,7 @@
           <p:spPr>
             <a:xfrm>
               <a:off x="735330" y="3019425"/>
-              <a:ext cx="2955747" cy="293370"/>
+              <a:ext cx="3321520" cy="293370"/>
             </a:xfrm>
             <a:prstGeom prst="rect">
               <a:avLst/>
@@ -4907,7 +4907,7 @@
                   <a:ea typeface="+mn-ea"/>
                   <a:cs typeface="+mn-cs"/>
                 </a:rPr>
-                <a:t>Local FCI+ · Claassen profile</a:t>
+                <a:t>Local FCI Plus · Claassen profile</a:t>
               </a:r>
             </a:p>
           </p:txBody>
@@ -4921,7 +4921,7 @@
           <p:spPr>
             <a:xfrm>
               <a:off x="735330" y="3495675"/>
-              <a:ext cx="3024871" cy="293370"/>
+              <a:ext cx="3391008" cy="293370"/>
             </a:xfrm>
             <a:prstGeom prst="rect">
               <a:avLst/>
@@ -4947,7 +4947,7 @@
                   <a:ea typeface="+mn-ea"/>
                   <a:cs typeface="+mn-cs"/>
                 </a:rPr>
-                <a:t>Local FCI+ · robust workflow</a:t>
+                <a:t>Local FCI Plus · robust workflow</a:t>
               </a:r>
             </a:p>
           </p:txBody>
@@ -5001,7 +5001,7 @@
           <p:spPr>
             <a:xfrm>
               <a:off x="735330" y="4448175"/>
-              <a:ext cx="2007289" cy="293370"/>
+              <a:ext cx="2369934" cy="293370"/>
             </a:xfrm>
             <a:prstGeom prst="rect">
               <a:avLst/>
@@ -5027,7 +5027,7 @@
                   <a:ea typeface="+mn-ea"/>
                   <a:cs typeface="+mn-cs"/>
                 </a:rPr>
-                <a:t>pcalg FCI+ · 2.7-12</a:t>
+                <a:t>pcalg FCI Plus · 2.7-12</a:t>
               </a:r>
             </a:p>
           </p:txBody>
@@ -5839,10 +5839,10 @@
         </p:nvGrpSpPr>
         <p:grpSpPr>
           <a:xfrm>
-            <a:off x="533400" y="1162050"/>
-            <a:ext cx="4928479" cy="248031"/>
-            <a:chOff x="533400" y="1162050"/>
-            <a:chExt cx="4928479" cy="248031"/>
+            <a:off x="533400" y="1133475"/>
+            <a:ext cx="4619625" cy="228600"/>
+            <a:chOff x="533400" y="1133475"/>
+            <a:chExt cx="4619625" cy="228600"/>
           </a:xfrm>
         </p:grpSpPr>
         <p:sp>
@@ -5877,26 +5877,26 @@
           </p:nvSpPr>
           <p:spPr>
             <a:xfrm>
-              <a:off x="774954" y="1175385"/>
-              <a:ext cx="1947794" cy="234696"/>
-            </a:xfrm>
-            <a:prstGeom prst="rect">
-              <a:avLst/>
-            </a:prstGeom>
-            <a:noFill/>
-            <a:ln>
-              <a:noFill/>
-            </a:ln>
-          </p:spPr>
-          <p:txBody>
-            <a:bodyPr wrap="none" lIns="0" tIns="0" rIns="0" bIns="0" anchor="t" anchorCtr="0">
-              <a:spAutoFit/>
+              <a:off x="781050" y="1133475"/>
+              <a:ext cx="1809750" cy="228600"/>
+            </a:xfrm>
+            <a:prstGeom prst="rect">
+              <a:avLst/>
+            </a:prstGeom>
+            <a:noFill/>
+            <a:ln>
+              <a:noFill/>
+            </a:ln>
+          </p:spPr>
+          <p:txBody>
+            <a:bodyPr wrap="square" lIns="0" tIns="50006" rIns="0" bIns="0" anchor="t" anchorCtr="0">
+              <a:noAutofit/>
             </a:bodyPr>
             <a:lstStyle/>
             <a:p>
               <a:pPr algn="l"/>
               <a:r>
-                <a:rPr lang="en-US" sz="1200" b="1" dirty="0">
+                <a:rPr lang="en-US" sz="1120" b="1" dirty="0">
                   <a:solidFill>
                     <a:srgbClr val="2E7D5B"/>
                   </a:solidFill>
@@ -5904,7 +5904,7 @@
                   <a:ea typeface="+mn-ea"/>
                   <a:cs typeface="+mn-cs"/>
                 </a:rPr>
-                <a:t>DESIGN-BASED EVIDENCE</a:t>
+                <a:t>DESIGN-BASED</a:t>
               </a:r>
             </a:p>
           </p:txBody>
@@ -5941,26 +5941,26 @@
           </p:nvSpPr>
           <p:spPr>
             <a:xfrm>
-              <a:off x="3146679" y="1175385"/>
-              <a:ext cx="2315200" cy="234696"/>
-            </a:xfrm>
-            <a:prstGeom prst="rect">
-              <a:avLst/>
-            </a:prstGeom>
-            <a:noFill/>
-            <a:ln>
-              <a:noFill/>
-            </a:ln>
-          </p:spPr>
-          <p:txBody>
-            <a:bodyPr wrap="none" lIns="0" tIns="0" rIns="0" bIns="0" anchor="t" anchorCtr="0">
-              <a:spAutoFit/>
+              <a:off x="3152775" y="1133475"/>
+              <a:ext cx="2000250" cy="228600"/>
+            </a:xfrm>
+            <a:prstGeom prst="rect">
+              <a:avLst/>
+            </a:prstGeom>
+            <a:noFill/>
+            <a:ln>
+              <a:noFill/>
+            </a:ln>
+          </p:spPr>
+          <p:txBody>
+            <a:bodyPr wrap="square" lIns="0" tIns="50006" rIns="0" bIns="0" anchor="t" anchorCtr="0">
+              <a:noAutofit/>
             </a:bodyPr>
             <a:lstStyle/>
             <a:p>
               <a:pPr algn="l"/>
               <a:r>
-                <a:rPr lang="en-US" sz="1200" b="1" dirty="0">
+                <a:rPr lang="en-US" sz="1120" b="1" dirty="0">
                   <a:solidFill>
                     <a:schemeClr val="accent2"/>
                   </a:solidFill>
@@ -5968,7 +5968,7 @@
                   <a:ea typeface="+mn-ea"/>
                   <a:cs typeface="+mn-cs"/>
                 </a:rPr>
-                <a:t>EXPLORATORY PAG EVIDENCE</a:t>
+                <a:t>EXPLORATORY PAG</a:t>
               </a:r>
             </a:p>
           </p:txBody>
@@ -7406,10 +7406,10 @@
         </p:nvGrpSpPr>
         <p:grpSpPr>
           <a:xfrm>
-            <a:off x="533400" y="1162050"/>
-            <a:ext cx="8154589" cy="248031"/>
-            <a:chOff x="533400" y="1162050"/>
-            <a:chExt cx="8154589" cy="248031"/>
+            <a:off x="533400" y="1133475"/>
+            <a:ext cx="7239000" cy="228600"/>
+            <a:chOff x="533400" y="1133475"/>
+            <a:chExt cx="7239000" cy="228600"/>
           </a:xfrm>
         </p:grpSpPr>
         <p:sp>
@@ -7444,26 +7444,26 @@
           </p:nvSpPr>
           <p:spPr>
             <a:xfrm>
-              <a:off x="774954" y="1175385"/>
-              <a:ext cx="3094817" cy="234696"/>
-            </a:xfrm>
-            <a:prstGeom prst="rect">
-              <a:avLst/>
-            </a:prstGeom>
-            <a:noFill/>
-            <a:ln>
-              <a:noFill/>
-            </a:ln>
-          </p:spPr>
-          <p:txBody>
-            <a:bodyPr wrap="none" lIns="0" tIns="0" rIns="0" bIns="0" anchor="t" anchorCtr="0">
-              <a:spAutoFit/>
+              <a:off x="781050" y="1133475"/>
+              <a:ext cx="2667000" cy="228600"/>
+            </a:xfrm>
+            <a:prstGeom prst="rect">
+              <a:avLst/>
+            </a:prstGeom>
+            <a:noFill/>
+            <a:ln>
+              <a:noFill/>
+            </a:ln>
+          </p:spPr>
+          <p:txBody>
+            <a:bodyPr wrap="square" lIns="0" tIns="50006" rIns="0" bIns="0" anchor="t" anchorCtr="0">
+              <a:noAutofit/>
             </a:bodyPr>
             <a:lstStyle/>
             <a:p>
               <a:pPr algn="l"/>
               <a:r>
-                <a:rPr lang="en-US" sz="1200" b="1" dirty="0">
+                <a:rPr lang="en-US" sz="1120" b="1" dirty="0">
                   <a:solidFill>
                     <a:srgbClr val="2E7D5B"/>
                   </a:solidFill>
@@ -7471,7 +7471,7 @@
                   <a:ea typeface="+mn-ea"/>
                   <a:cs typeface="+mn-cs"/>
                 </a:rPr>
-                <a:t>RANDOMIZED KINDERGARTEN CONTRAST</a:t>
+                <a:t>RANDOMIZED K CONTRAST</a:t>
               </a:r>
             </a:p>
           </p:txBody>
@@ -7508,26 +7508,26 @@
           </p:nvSpPr>
           <p:spPr>
             <a:xfrm>
-              <a:off x="4813554" y="1175385"/>
-              <a:ext cx="3874435" cy="234696"/>
-            </a:xfrm>
-            <a:prstGeom prst="rect">
-              <a:avLst/>
-            </a:prstGeom>
-            <a:noFill/>
-            <a:ln>
-              <a:noFill/>
-            </a:ln>
-          </p:spPr>
-          <p:txBody>
-            <a:bodyPr wrap="none" lIns="0" tIns="0" rIns="0" bIns="0" anchor="t" anchorCtr="0">
-              <a:spAutoFit/>
+              <a:off x="4819650" y="1133475"/>
+              <a:ext cx="2952750" cy="228600"/>
+            </a:xfrm>
+            <a:prstGeom prst="rect">
+              <a:avLst/>
+            </a:prstGeom>
+            <a:noFill/>
+            <a:ln>
+              <a:noFill/>
+            </a:ln>
+          </p:spPr>
+          <p:txBody>
+            <a:bodyPr wrap="square" lIns="0" tIns="50006" rIns="0" bIns="0" anchor="t" anchorCtr="0">
+              <a:noAutofit/>
             </a:bodyPr>
             <a:lstStyle/>
             <a:p>
               <a:pPr algn="l"/>
               <a:r>
-                <a:rPr lang="en-US" sz="1200" b="1" dirty="0">
+                <a:rPr lang="en-US" sz="1120" b="1" dirty="0">
                   <a:solidFill>
                     <a:schemeClr val="accent3"/>
                   </a:solidFill>
@@ -7535,7 +7535,7 @@
                   <a:ea typeface="+mn-ea"/>
                   <a:cs typeface="+mn-cs"/>
                 </a:rPr>
-                <a:t>DESCRIPTIVE GRADE-3 FOLLOW-UP (OBSERVED)</a:t>
+                <a:t>OBSERVED GRADE-3 FOLLOW-UP</a:t>
               </a:r>
             </a:p>
           </p:txBody>
@@ -8531,20 +8531,20 @@
           </p:nvSpPr>
           <p:spPr>
             <a:xfrm>
-              <a:off x="8737092" y="1825942"/>
-              <a:ext cx="2171106" cy="264033"/>
-            </a:xfrm>
-            <a:prstGeom prst="rect">
-              <a:avLst/>
-            </a:prstGeom>
-            <a:noFill/>
-            <a:ln>
-              <a:noFill/>
-            </a:ln>
-          </p:spPr>
-          <p:txBody>
-            <a:bodyPr wrap="none" lIns="0" tIns="0" rIns="0" bIns="0" anchor="t" anchorCtr="0">
-              <a:spAutoFit/>
+              <a:off x="8743950" y="1752600"/>
+              <a:ext cx="2533650" cy="285750"/>
+            </a:xfrm>
+            <a:prstGeom prst="rect">
+              <a:avLst/>
+            </a:prstGeom>
+            <a:noFill/>
+            <a:ln>
+              <a:noFill/>
+            </a:ln>
+          </p:spPr>
+          <p:txBody>
+            <a:bodyPr wrap="square" lIns="0" tIns="73342" rIns="0" bIns="0" anchor="t" anchorCtr="0">
+              <a:noAutofit/>
             </a:bodyPr>
             <a:lstStyle/>
             <a:p>
@@ -8571,26 +8571,26 @@
           </p:nvSpPr>
           <p:spPr>
             <a:xfrm>
-              <a:off x="8731758" y="2169795"/>
-              <a:ext cx="2408042" cy="469392"/>
-            </a:xfrm>
-            <a:prstGeom prst="rect">
-              <a:avLst/>
-            </a:prstGeom>
-            <a:noFill/>
-            <a:ln>
-              <a:noFill/>
-            </a:ln>
-          </p:spPr>
-          <p:txBody>
-            <a:bodyPr wrap="none" lIns="0" tIns="0" rIns="0" bIns="0" anchor="t" anchorCtr="0">
-              <a:spAutoFit/>
+              <a:off x="8743950" y="2095500"/>
+              <a:ext cx="2628900" cy="419100"/>
+            </a:xfrm>
+            <a:prstGeom prst="rect">
+              <a:avLst/>
+            </a:prstGeom>
+            <a:noFill/>
+            <a:ln>
+              <a:noFill/>
+            </a:ln>
+          </p:spPr>
+          <p:txBody>
+            <a:bodyPr wrap="square" lIns="0" tIns="90488" rIns="0" bIns="0" anchor="t" anchorCtr="0">
+              <a:noAutofit/>
             </a:bodyPr>
             <a:lstStyle/>
             <a:p>
               <a:pPr algn="l"/>
               <a:r>
-                <a:rPr lang="en-US" sz="2400" b="1" dirty="0">
+                <a:rPr lang="en-US" sz="2250" b="1" dirty="0">
                   <a:solidFill>
                     <a:srgbClr val="FFFFFF"/>
                   </a:solidFill>
@@ -8598,7 +8598,7 @@
                   <a:ea typeface="+mj-ea"/>
                   <a:cs typeface="+mj-cs"/>
                 </a:rPr>
-                <a:t>+13.90 points</a:t>
+                <a:t>13.90 points</a:t>
               </a:r>
             </a:p>
           </p:txBody>
@@ -8727,26 +8727,26 @@
           </p:nvSpPr>
           <p:spPr>
             <a:xfrm>
-              <a:off x="8732520" y="3538538"/>
-              <a:ext cx="2072716" cy="440055"/>
-            </a:xfrm>
-            <a:prstGeom prst="rect">
-              <a:avLst/>
-            </a:prstGeom>
-            <a:noFill/>
-            <a:ln>
-              <a:noFill/>
-            </a:ln>
-          </p:spPr>
-          <p:txBody>
-            <a:bodyPr wrap="none" lIns="0" tIns="0" rIns="0" bIns="0" anchor="t" anchorCtr="0">
-              <a:spAutoFit/>
+              <a:off x="8743950" y="3467100"/>
+              <a:ext cx="2628900" cy="400050"/>
+            </a:xfrm>
+            <a:prstGeom prst="rect">
+              <a:avLst/>
+            </a:prstGeom>
+            <a:noFill/>
+            <a:ln>
+              <a:noFill/>
+            </a:ln>
+          </p:spPr>
+          <p:txBody>
+            <a:bodyPr wrap="square" lIns="0" tIns="87630" rIns="0" bIns="0" anchor="t" anchorCtr="0">
+              <a:noAutofit/>
             </a:bodyPr>
             <a:lstStyle/>
             <a:p>
               <a:pPr algn="l"/>
               <a:r>
-                <a:rPr lang="en-US" sz="2250" b="1" dirty="0">
+                <a:rPr lang="en-US" sz="2100" b="1" dirty="0">
                   <a:solidFill>
                     <a:srgbClr val="FFFFFF"/>
                   </a:solidFill>
@@ -8754,7 +8754,7 @@
                   <a:ea typeface="+mj-ea"/>
                   <a:cs typeface="+mj-cs"/>
                 </a:rPr>
-                <a:t>+0.31 points</a:t>
+                <a:t>0.31 points</a:t>
               </a:r>
             </a:p>
           </p:txBody>
@@ -9364,10 +9364,10 @@
         </p:nvGrpSpPr>
         <p:grpSpPr>
           <a:xfrm>
-            <a:off x="533400" y="1162050"/>
-            <a:ext cx="6331153" cy="248031"/>
-            <a:chOff x="533400" y="1162050"/>
-            <a:chExt cx="6331153" cy="248031"/>
+            <a:off x="533400" y="1133475"/>
+            <a:ext cx="6429375" cy="228600"/>
+            <a:chOff x="533400" y="1133475"/>
+            <a:chExt cx="6429375" cy="228600"/>
           </a:xfrm>
         </p:grpSpPr>
         <p:sp>
@@ -9402,26 +9402,26 @@
           </p:nvSpPr>
           <p:spPr>
             <a:xfrm>
-              <a:off x="774954" y="1175385"/>
-              <a:ext cx="1544544" cy="234696"/>
-            </a:xfrm>
-            <a:prstGeom prst="rect">
-              <a:avLst/>
-            </a:prstGeom>
-            <a:noFill/>
-            <a:ln>
-              <a:noFill/>
-            </a:ln>
-          </p:spPr>
-          <p:txBody>
-            <a:bodyPr wrap="none" lIns="0" tIns="0" rIns="0" bIns="0" anchor="t" anchorCtr="0">
-              <a:spAutoFit/>
+              <a:off x="781050" y="1133475"/>
+              <a:ext cx="1476375" cy="228600"/>
+            </a:xfrm>
+            <a:prstGeom prst="rect">
+              <a:avLst/>
+            </a:prstGeom>
+            <a:noFill/>
+            <a:ln>
+              <a:noFill/>
+            </a:ln>
+          </p:spPr>
+          <p:txBody>
+            <a:bodyPr wrap="square" lIns="0" tIns="50006" rIns="0" bIns="0" anchor="t" anchorCtr="0">
+              <a:noAutofit/>
             </a:bodyPr>
             <a:lstStyle/>
             <a:p>
               <a:pPr algn="l"/>
               <a:r>
-                <a:rPr lang="en-US" sz="1200" b="1" dirty="0">
+                <a:rPr lang="en-US" sz="1120" b="1" dirty="0">
                   <a:solidFill>
                     <a:srgbClr val="2E7D5B"/>
                   </a:solidFill>
@@ -9466,26 +9466,26 @@
           </p:nvSpPr>
           <p:spPr>
             <a:xfrm>
-              <a:off x="2670429" y="1175385"/>
-              <a:ext cx="1876105" cy="234696"/>
-            </a:xfrm>
-            <a:prstGeom prst="rect">
-              <a:avLst/>
-            </a:prstGeom>
-            <a:noFill/>
-            <a:ln>
-              <a:noFill/>
-            </a:ln>
-          </p:spPr>
-          <p:txBody>
-            <a:bodyPr wrap="none" lIns="0" tIns="0" rIns="0" bIns="0" anchor="t" anchorCtr="0">
-              <a:spAutoFit/>
+              <a:off x="2676525" y="1133475"/>
+              <a:ext cx="1857375" cy="228600"/>
+            </a:xfrm>
+            <a:prstGeom prst="rect">
+              <a:avLst/>
+            </a:prstGeom>
+            <a:noFill/>
+            <a:ln>
+              <a:noFill/>
+            </a:ln>
+          </p:spPr>
+          <p:txBody>
+            <a:bodyPr wrap="square" lIns="0" tIns="50006" rIns="0" bIns="0" anchor="t" anchorCtr="0">
+              <a:noAutofit/>
             </a:bodyPr>
             <a:lstStyle/>
             <a:p>
               <a:pPr algn="l"/>
               <a:r>
-                <a:rPr lang="en-US" sz="1200" b="1" dirty="0">
+                <a:rPr lang="en-US" sz="1120" b="1" dirty="0">
                   <a:solidFill>
                     <a:srgbClr val="B45F4A"/>
                   </a:solidFill>
@@ -9493,7 +9493,7 @@
                   <a:ea typeface="+mn-ea"/>
                   <a:cs typeface="+mn-cs"/>
                 </a:rPr>
-                <a:t>DIRECTIONAL CONFLICT</a:t>
+                <a:t>DIRECTION CONFLICT</a:t>
               </a:r>
             </a:p>
           </p:txBody>
@@ -9532,26 +9532,26 @@
           </p:nvSpPr>
           <p:spPr>
             <a:xfrm>
-              <a:off x="5194554" y="1175385"/>
-              <a:ext cx="1669999" cy="234696"/>
-            </a:xfrm>
-            <a:prstGeom prst="rect">
-              <a:avLst/>
-            </a:prstGeom>
-            <a:noFill/>
-            <a:ln>
-              <a:noFill/>
-            </a:ln>
-          </p:spPr>
-          <p:txBody>
-            <a:bodyPr wrap="none" lIns="0" tIns="0" rIns="0" bIns="0" anchor="t" anchorCtr="0">
-              <a:spAutoFit/>
+              <a:off x="5200650" y="1133475"/>
+              <a:ext cx="1762125" cy="228600"/>
+            </a:xfrm>
+            <a:prstGeom prst="rect">
+              <a:avLst/>
+            </a:prstGeom>
+            <a:noFill/>
+            <a:ln>
+              <a:noFill/>
+            </a:ln>
+          </p:spPr>
+          <p:txBody>
+            <a:bodyPr wrap="square" lIns="0" tIns="50006" rIns="0" bIns="0" anchor="t" anchorCtr="0">
+              <a:noAutofit/>
             </a:bodyPr>
             <a:lstStyle/>
             <a:p>
               <a:pPr algn="l"/>
               <a:r>
-                <a:rPr lang="en-US" sz="1200" b="1" dirty="0">
+                <a:rPr lang="en-US" sz="1120" b="1" dirty="0">
                   <a:solidFill>
                     <a:schemeClr val="accent6"/>
                   </a:solidFill>
@@ -9613,20 +9613,20 @@
           </p:nvSpPr>
           <p:spPr>
             <a:xfrm>
-              <a:off x="774192" y="1835468"/>
-              <a:ext cx="3441344" cy="264033"/>
-            </a:xfrm>
-            <a:prstGeom prst="rect">
-              <a:avLst/>
-            </a:prstGeom>
-            <a:noFill/>
-            <a:ln>
-              <a:noFill/>
-            </a:ln>
-          </p:spPr>
-          <p:txBody>
-            <a:bodyPr wrap="none" lIns="0" tIns="0" rIns="0" bIns="0" anchor="t" anchorCtr="0">
-              <a:spAutoFit/>
+              <a:off x="781050" y="1762125"/>
+              <a:ext cx="3429000" cy="285750"/>
+            </a:xfrm>
+            <a:prstGeom prst="rect">
+              <a:avLst/>
+            </a:prstGeom>
+            <a:noFill/>
+            <a:ln>
+              <a:noFill/>
+            </a:ln>
+          </p:spPr>
+          <p:txBody>
+            <a:bodyPr wrap="square" lIns="0" tIns="73342" rIns="0" bIns="0" anchor="t" anchorCtr="0">
+              <a:noAutofit/>
             </a:bodyPr>
             <a:lstStyle/>
             <a:p>
@@ -9640,7 +9640,7 @@
                   <a:ea typeface="+mn-ea"/>
                   <a:cs typeface="+mn-cs"/>
                 </a:rPr>
-                <a:t>EXACT BASELINE-PAG REPRODUCTIONS</a:t>
+                <a:t>ORDER-SHIFT REPRODUCTIONS</a:t>
               </a:r>
             </a:p>
           </p:txBody>
@@ -9734,7 +9734,7 @@
           <p:spPr>
             <a:xfrm>
               <a:off x="3336417" y="2216468"/>
-              <a:ext cx="988088" cy="264033"/>
+              <a:ext cx="1316359" cy="264033"/>
             </a:xfrm>
             <a:prstGeom prst="rect">
               <a:avLst/>
@@ -9760,7 +9760,7 @@
                   <a:ea typeface="+mn-ea"/>
                   <a:cs typeface="+mn-cs"/>
                 </a:rPr>
-                <a:t>paper FCI+</a:t>
+                <a:t>paper FCI Plus</a:t>
               </a:r>
             </a:p>
           </p:txBody>
@@ -10896,7 +10896,7 @@
           <p:spPr>
             <a:xfrm>
               <a:off x="6393942" y="2730818"/>
-              <a:ext cx="988088" cy="264033"/>
+              <a:ext cx="1316359" cy="264033"/>
             </a:xfrm>
             <a:prstGeom prst="rect">
               <a:avLst/>
@@ -10922,7 +10922,7 @@
                   <a:ea typeface="+mn-ea"/>
                   <a:cs typeface="+mn-cs"/>
                 </a:rPr>
-                <a:t>paper FCI+</a:t>
+                <a:t>paper FCI Plus</a:t>
               </a:r>
             </a:p>
           </p:txBody>
@@ -11076,7 +11076,7 @@
           <p:spPr>
             <a:xfrm>
               <a:off x="6393942" y="3378518"/>
-              <a:ext cx="1109213" cy="264033"/>
+              <a:ext cx="1437057" cy="264033"/>
             </a:xfrm>
             <a:prstGeom prst="rect">
               <a:avLst/>
@@ -11102,7 +11102,7 @@
                   <a:ea typeface="+mn-ea"/>
                   <a:cs typeface="+mn-cs"/>
                 </a:rPr>
-                <a:t>R pcalg FCI+</a:t>
+                <a:t>R pcalg FCI Plus</a:t>
               </a:r>
             </a:p>
           </p:txBody>
@@ -11240,7 +11240,7 @@
           <p:spPr>
             <a:xfrm>
               <a:off x="6393942" y="4026218"/>
-              <a:ext cx="1092771" cy="264033"/>
+              <a:ext cx="1421284" cy="264033"/>
             </a:xfrm>
             <a:prstGeom prst="rect">
               <a:avLst/>
@@ -11266,7 +11266,7 @@
                   <a:ea typeface="+mn-ea"/>
                   <a:cs typeface="+mn-cs"/>
                 </a:rPr>
-                <a:t>robust FCI+</a:t>
+                <a:t>robust FCI Plus</a:t>
               </a:r>
             </a:p>
           </p:txBody>
@@ -11401,9 +11401,9 @@
         <p:grpSpPr>
           <a:xfrm>
             <a:off x="533400" y="5400675"/>
-            <a:ext cx="11125200" cy="674370"/>
+            <a:ext cx="11125200" cy="657225"/>
             <a:chOff x="533400" y="5400675"/>
-            <a:chExt cx="11125200" cy="674370"/>
+            <a:chExt cx="11125200" cy="657225"/>
           </a:xfrm>
         </p:grpSpPr>
         <p:sp>
@@ -11438,20 +11438,20 @@
           </p:nvSpPr>
           <p:spPr>
             <a:xfrm>
-              <a:off x="755142" y="5531168"/>
-              <a:ext cx="1908993" cy="264033"/>
-            </a:xfrm>
-            <a:prstGeom prst="rect">
-              <a:avLst/>
-            </a:prstGeom>
-            <a:noFill/>
-            <a:ln>
-              <a:noFill/>
-            </a:ln>
-          </p:spPr>
-          <p:txBody>
-            <a:bodyPr wrap="none" lIns="0" tIns="0" rIns="0" bIns="0" anchor="t" anchorCtr="0">
-              <a:spAutoFit/>
+              <a:off x="762000" y="5476875"/>
+              <a:ext cx="2190750" cy="247650"/>
+            </a:xfrm>
+            <a:prstGeom prst="rect">
+              <a:avLst/>
+            </a:prstGeom>
+            <a:noFill/>
+            <a:ln>
+              <a:noFill/>
+            </a:ln>
+          </p:spPr>
+          <p:txBody>
+            <a:bodyPr wrap="square" lIns="0" tIns="54293" rIns="0" bIns="0" anchor="t" anchorCtr="0">
+              <a:noAutofit/>
             </a:bodyPr>
             <a:lstStyle/>
             <a:p>
@@ -11478,26 +11478,26 @@
           </p:nvSpPr>
           <p:spPr>
             <a:xfrm>
-              <a:off x="754380" y="5781675"/>
-              <a:ext cx="10603418" cy="293370"/>
-            </a:xfrm>
-            <a:prstGeom prst="rect">
-              <a:avLst/>
-            </a:prstGeom>
-            <a:noFill/>
-            <a:ln>
-              <a:noFill/>
-            </a:ln>
-          </p:spPr>
-          <p:txBody>
-            <a:bodyPr wrap="none" lIns="0" tIns="0" rIns="0" bIns="0" anchor="t" anchorCtr="0">
-              <a:spAutoFit/>
+              <a:off x="762000" y="5734050"/>
+              <a:ext cx="10572750" cy="266700"/>
+            </a:xfrm>
+            <a:prstGeom prst="rect">
+              <a:avLst/>
+            </a:prstGeom>
+            <a:noFill/>
+            <a:ln>
+              <a:noFill/>
+            </a:ln>
+          </p:spPr>
+          <p:txBody>
+            <a:bodyPr wrap="square" lIns="0" tIns="55721" rIns="0" bIns="0" anchor="t" anchorCtr="0">
+              <a:noAutofit/>
             </a:bodyPr>
             <a:lstStyle/>
             <a:p>
               <a:pPr algn="l"/>
               <a:r>
-                <a:rPr lang="en-US" sz="1500" dirty="0">
+                <a:rPr lang="en-US" sz="1420" dirty="0">
                   <a:solidFill>
                     <a:schemeClr val="dk1"/>
                   </a:solidFill>
@@ -11505,7 +11505,7 @@
                   <a:ea typeface="+mn-ea"/>
                   <a:cs typeface="+mn-cs"/>
                 </a:rPr>
-                <a:t>Early achievement—later achievement and early achievement—observation: 100% local bootstrap frequency.</a:t>
+                <a:t>Early–later achievement and early achievement–observation: 100% local bootstrap frequency.</a:t>
               </a:r>
             </a:p>
           </p:txBody>
@@ -11650,10 +11650,10 @@
         </p:nvGrpSpPr>
         <p:grpSpPr>
           <a:xfrm>
-            <a:off x="518160" y="361950"/>
-            <a:ext cx="11147298" cy="657225"/>
-            <a:chOff x="518160" y="361950"/>
-            <a:chExt cx="11147298" cy="657225"/>
+            <a:off x="518541" y="370046"/>
+            <a:ext cx="11146917" cy="649129"/>
+            <a:chOff x="518541" y="370046"/>
+            <a:chExt cx="11146917" cy="649129"/>
           </a:xfrm>
         </p:grpSpPr>
         <p:sp>
@@ -11664,8 +11664,8 @@
           </p:nvSpPr>
           <p:spPr>
             <a:xfrm>
-              <a:off x="518160" y="361950"/>
-              <a:ext cx="10426979" cy="586740"/>
+              <a:off x="518541" y="370046"/>
+              <a:ext cx="10928364" cy="572072"/>
             </a:xfrm>
             <a:prstGeom prst="rect">
               <a:avLst/>
@@ -11683,7 +11683,7 @@
             <a:p>
               <a:pPr algn="l"/>
               <a:r>
-                <a:rPr lang="en-US" sz="3000" b="1" dirty="0">
+                <a:rPr lang="en-US" sz="2920" b="1" dirty="0">
                   <a:solidFill>
                     <a:schemeClr val="accent1"/>
                   </a:solidFill>
@@ -11691,7 +11691,7 @@
                   <a:ea typeface="+mj-ea"/>
                   <a:cs typeface="+mj-cs"/>
                 </a:rPr>
-                <a:t>FCI+ Reduces CI Work, Not Causal Uncertainty</a:t>
+                <a:t>FCI Plus Reduces CI Work, Not Causal Uncertainty</a:t>
               </a:r>
             </a:p>
           </p:txBody>
@@ -13220,7 +13220,7 @@
           <p:spPr>
             <a:xfrm>
               <a:off x="754380" y="5457825"/>
-              <a:ext cx="2624884" cy="293370"/>
+              <a:ext cx="2987411" cy="293370"/>
             </a:xfrm>
             <a:prstGeom prst="rect">
               <a:avLst/>
@@ -13246,7 +13246,7 @@
                   <a:ea typeface="+mn-ea"/>
                   <a:cs typeface="+mn-cs"/>
                 </a:rPr>
-                <a:t>Paper FCI+ / FCI CI work:</a:t>
+                <a:t>Paper FCI Plus / FCI CI work:</a:t>
               </a:r>
             </a:p>
           </p:txBody>
@@ -13566,10 +13566,10 @@
         </p:nvGrpSpPr>
         <p:grpSpPr>
           <a:xfrm>
-            <a:off x="526542" y="1664018"/>
-            <a:ext cx="5188458" cy="3359657"/>
-            <a:chOff x="526542" y="1664018"/>
-            <a:chExt cx="5188458" cy="3359657"/>
+            <a:off x="533400" y="1590675"/>
+            <a:ext cx="5181600" cy="3419475"/>
+            <a:chOff x="533400" y="1590675"/>
+            <a:chExt cx="5181600" cy="3419475"/>
           </a:xfrm>
         </p:grpSpPr>
         <p:sp>
@@ -13580,20 +13580,20 @@
           </p:nvSpPr>
           <p:spPr>
             <a:xfrm>
-              <a:off x="526542" y="1664018"/>
-              <a:ext cx="3481669" cy="264033"/>
-            </a:xfrm>
-            <a:prstGeom prst="rect">
-              <a:avLst/>
-            </a:prstGeom>
-            <a:noFill/>
-            <a:ln>
-              <a:noFill/>
-            </a:ln>
-          </p:spPr>
-          <p:txBody>
-            <a:bodyPr wrap="none" lIns="0" tIns="0" rIns="0" bIns="0" anchor="t" anchorCtr="0">
-              <a:spAutoFit/>
+              <a:off x="533400" y="1590675"/>
+              <a:ext cx="3714750" cy="285750"/>
+            </a:xfrm>
+            <a:prstGeom prst="rect">
+              <a:avLst/>
+            </a:prstGeom>
+            <a:noFill/>
+            <a:ln>
+              <a:noFill/>
+            </a:ln>
+          </p:spPr>
+          <p:txBody>
+            <a:bodyPr wrap="square" lIns="0" tIns="73342" rIns="0" bIns="0" anchor="t" anchorCtr="0">
+              <a:noAutofit/>
             </a:bodyPr>
             <a:lstStyle/>
             <a:p>
@@ -13663,26 +13663,26 @@
           </p:nvSpPr>
           <p:spPr>
             <a:xfrm>
-              <a:off x="2261509" y="2186940"/>
-              <a:ext cx="1725381" cy="352044"/>
-            </a:xfrm>
-            <a:prstGeom prst="rect">
-              <a:avLst/>
-            </a:prstGeom>
-            <a:noFill/>
-            <a:ln>
-              <a:noFill/>
-            </a:ln>
-          </p:spPr>
-          <p:txBody>
-            <a:bodyPr wrap="none" lIns="0" tIns="0" rIns="0" bIns="0" anchor="t" anchorCtr="0">
-              <a:spAutoFit/>
+              <a:off x="990600" y="2152650"/>
+              <a:ext cx="4267200" cy="266700"/>
+            </a:xfrm>
+            <a:prstGeom prst="rect">
+              <a:avLst/>
+            </a:prstGeom>
+            <a:noFill/>
+            <a:ln>
+              <a:noFill/>
+            </a:ln>
+          </p:spPr>
+          <p:txBody>
+            <a:bodyPr wrap="square" lIns="0" tIns="47625" rIns="0" bIns="0" anchor="t" anchorCtr="0">
+              <a:noAutofit/>
             </a:bodyPr>
             <a:lstStyle/>
             <a:p>
               <a:pPr algn="ctr"/>
               <a:r>
-                <a:rPr lang="en-US" sz="1800" b="1" dirty="0">
+                <a:rPr lang="en-US" sz="1500" b="1" dirty="0">
                   <a:solidFill>
                     <a:srgbClr val="FFFFFF"/>
                   </a:solidFill>
@@ -13703,26 +13703,26 @@
           </p:nvSpPr>
           <p:spPr>
             <a:xfrm>
-              <a:off x="1257629" y="2473642"/>
-              <a:ext cx="3733143" cy="264033"/>
-            </a:xfrm>
-            <a:prstGeom prst="rect">
-              <a:avLst/>
-            </a:prstGeom>
-            <a:noFill/>
-            <a:ln>
-              <a:noFill/>
-            </a:ln>
-          </p:spPr>
-          <p:txBody>
-            <a:bodyPr wrap="none" lIns="0" tIns="0" rIns="0" bIns="0" anchor="t" anchorCtr="0">
-              <a:spAutoFit/>
+              <a:off x="1047750" y="2390775"/>
+              <a:ext cx="4152900" cy="247650"/>
+            </a:xfrm>
+            <a:prstGeom prst="rect">
+              <a:avLst/>
+            </a:prstGeom>
+            <a:noFill/>
+            <a:ln>
+              <a:noFill/>
+            </a:ln>
+          </p:spPr>
+          <p:txBody>
+            <a:bodyPr wrap="square" lIns="0" tIns="88106" rIns="0" bIns="0" anchor="t" anchorCtr="0">
+              <a:noAutofit/>
             </a:bodyPr>
             <a:lstStyle/>
             <a:p>
               <a:pPr algn="ctr"/>
               <a:r>
-                <a:rPr lang="en-US" sz="1350" dirty="0">
+                <a:rPr lang="en-US" sz="1120" dirty="0">
                   <a:solidFill>
                     <a:srgbClr val="FFFFFF"/>
                   </a:solidFill>
@@ -13786,26 +13786,26 @@
           </p:nvSpPr>
           <p:spPr>
             <a:xfrm>
-              <a:off x="2375764" y="2948940"/>
-              <a:ext cx="1496873" cy="352044"/>
-            </a:xfrm>
-            <a:prstGeom prst="rect">
-              <a:avLst/>
-            </a:prstGeom>
-            <a:noFill/>
-            <a:ln>
-              <a:noFill/>
-            </a:ln>
-          </p:spPr>
-          <p:txBody>
-            <a:bodyPr wrap="none" lIns="0" tIns="0" rIns="0" bIns="0" anchor="t" anchorCtr="0">
-              <a:spAutoFit/>
+              <a:off x="1371600" y="2914650"/>
+              <a:ext cx="3505200" cy="266700"/>
+            </a:xfrm>
+            <a:prstGeom prst="rect">
+              <a:avLst/>
+            </a:prstGeom>
+            <a:noFill/>
+            <a:ln>
+              <a:noFill/>
+            </a:ln>
+          </p:spPr>
+          <p:txBody>
+            <a:bodyPr wrap="square" lIns="0" tIns="47625" rIns="0" bIns="0" anchor="t" anchorCtr="0">
+              <a:noAutofit/>
             </a:bodyPr>
             <a:lstStyle/>
             <a:p>
               <a:pPr algn="ctr"/>
               <a:r>
-                <a:rPr lang="en-US" sz="1800" b="1" dirty="0">
+                <a:rPr lang="en-US" sz="1500" b="1" dirty="0">
                   <a:solidFill>
                     <a:srgbClr val="FFFFFF"/>
                   </a:solidFill>
@@ -13826,26 +13826,26 @@
           </p:nvSpPr>
           <p:spPr>
             <a:xfrm>
-              <a:off x="1301665" y="3235642"/>
-              <a:ext cx="3645070" cy="264033"/>
-            </a:xfrm>
-            <a:prstGeom prst="rect">
-              <a:avLst/>
-            </a:prstGeom>
-            <a:noFill/>
-            <a:ln>
-              <a:noFill/>
-            </a:ln>
-          </p:spPr>
-          <p:txBody>
-            <a:bodyPr wrap="none" lIns="0" tIns="0" rIns="0" bIns="0" anchor="t" anchorCtr="0">
-              <a:spAutoFit/>
+              <a:off x="1428750" y="3152775"/>
+              <a:ext cx="3390900" cy="247650"/>
+            </a:xfrm>
+            <a:prstGeom prst="rect">
+              <a:avLst/>
+            </a:prstGeom>
+            <a:noFill/>
+            <a:ln>
+              <a:noFill/>
+            </a:ln>
+          </p:spPr>
+          <p:txBody>
+            <a:bodyPr wrap="square" lIns="0" tIns="88106" rIns="0" bIns="0" anchor="t" anchorCtr="0">
+              <a:noAutofit/>
             </a:bodyPr>
             <a:lstStyle/>
             <a:p>
               <a:pPr algn="ctr"/>
               <a:r>
-                <a:rPr lang="en-US" sz="1350" dirty="0">
+                <a:rPr lang="en-US" sz="1120" dirty="0">
                   <a:solidFill>
                     <a:srgbClr val="FFFFFF"/>
                   </a:solidFill>
@@ -13909,26 +13909,26 @@
           </p:nvSpPr>
           <p:spPr>
             <a:xfrm>
-              <a:off x="2483297" y="3710940"/>
-              <a:ext cx="1281806" cy="352044"/>
-            </a:xfrm>
-            <a:prstGeom prst="rect">
-              <a:avLst/>
-            </a:prstGeom>
-            <a:noFill/>
-            <a:ln>
-              <a:noFill/>
-            </a:ln>
-          </p:spPr>
-          <p:txBody>
-            <a:bodyPr wrap="none" lIns="0" tIns="0" rIns="0" bIns="0" anchor="t" anchorCtr="0">
-              <a:spAutoFit/>
+              <a:off x="1752600" y="3676650"/>
+              <a:ext cx="2743200" cy="266700"/>
+            </a:xfrm>
+            <a:prstGeom prst="rect">
+              <a:avLst/>
+            </a:prstGeom>
+            <a:noFill/>
+            <a:ln>
+              <a:noFill/>
+            </a:ln>
+          </p:spPr>
+          <p:txBody>
+            <a:bodyPr wrap="square" lIns="0" tIns="47625" rIns="0" bIns="0" anchor="t" anchorCtr="0">
+              <a:noAutofit/>
             </a:bodyPr>
             <a:lstStyle/>
             <a:p>
               <a:pPr algn="ctr"/>
               <a:r>
-                <a:rPr lang="en-US" sz="1800" b="1" dirty="0">
+                <a:rPr lang="en-US" sz="1500" b="1" dirty="0">
                   <a:solidFill>
                     <a:srgbClr val="FFFFFF"/>
                   </a:solidFill>
@@ -13949,26 +13949,26 @@
           </p:nvSpPr>
           <p:spPr>
             <a:xfrm>
-              <a:off x="1142705" y="3997642"/>
-              <a:ext cx="3962990" cy="264033"/>
-            </a:xfrm>
-            <a:prstGeom prst="rect">
-              <a:avLst/>
-            </a:prstGeom>
-            <a:noFill/>
-            <a:ln>
-              <a:noFill/>
-            </a:ln>
-          </p:spPr>
-          <p:txBody>
-            <a:bodyPr wrap="none" lIns="0" tIns="0" rIns="0" bIns="0" anchor="t" anchorCtr="0">
-              <a:spAutoFit/>
+              <a:off x="1809750" y="3914775"/>
+              <a:ext cx="2628900" cy="247650"/>
+            </a:xfrm>
+            <a:prstGeom prst="rect">
+              <a:avLst/>
+            </a:prstGeom>
+            <a:noFill/>
+            <a:ln>
+              <a:noFill/>
+            </a:ln>
+          </p:spPr>
+          <p:txBody>
+            <a:bodyPr wrap="square" lIns="0" tIns="88106" rIns="0" bIns="0" anchor="t" anchorCtr="0">
+              <a:noAutofit/>
             </a:bodyPr>
             <a:lstStyle/>
             <a:p>
               <a:pPr algn="ctr"/>
               <a:r>
-                <a:rPr lang="en-US" sz="1350" dirty="0">
+                <a:rPr lang="en-US" sz="1120" dirty="0">
                   <a:solidFill>
                     <a:srgbClr val="FFFFFF"/>
                   </a:solidFill>
@@ -13976,7 +13976,7 @@
                   <a:ea typeface="+mn-ea"/>
                   <a:cs typeface="+mn-cs"/>
                 </a:rPr>
-                <a:t>Later directions are specification-sensitive</a:t>
+                <a:t>Later directions vary by specification</a:t>
               </a:r>
             </a:p>
           </p:txBody>
@@ -13989,8 +13989,8 @@
           </p:nvSpPr>
           <p:spPr>
             <a:xfrm>
-              <a:off x="1752600" y="4381500"/>
-              <a:ext cx="2743200" cy="628650"/>
+              <a:off x="1562100" y="4381500"/>
+              <a:ext cx="3124200" cy="628650"/>
             </a:xfrm>
             <a:custGeom>
               <a:avLst/>
@@ -13999,15 +13999,15 @@
               <a:cxnLst/>
               <a:rect l="l" t="t" r="r" b="b"/>
               <a:pathLst>
-                <a:path w="2743200" h="628650">
+                <a:path w="3124200" h="628650">
                   <a:moveTo>
                     <a:pt x="0" y="0"/>
                   </a:moveTo>
                   <a:lnTo>
-                    <a:pt x="2743200" y="0"/>
+                    <a:pt x="3124200" y="0"/>
                   </a:lnTo>
                   <a:lnTo>
-                    <a:pt x="2362200" y="628650"/>
+                    <a:pt x="2743200" y="628650"/>
                   </a:lnTo>
                   <a:lnTo>
                     <a:pt x="381000" y="628650"/>
@@ -14032,26 +14032,26 @@
           </p:nvSpPr>
           <p:spPr>
             <a:xfrm>
-              <a:off x="2187580" y="4472940"/>
-              <a:ext cx="1873240" cy="352044"/>
-            </a:xfrm>
-            <a:prstGeom prst="rect">
-              <a:avLst/>
-            </a:prstGeom>
-            <a:noFill/>
-            <a:ln>
-              <a:noFill/>
-            </a:ln>
-          </p:spPr>
-          <p:txBody>
-            <a:bodyPr wrap="none" lIns="0" tIns="0" rIns="0" bIns="0" anchor="t" anchorCtr="0">
-              <a:spAutoFit/>
+              <a:off x="1657350" y="4438650"/>
+              <a:ext cx="2933700" cy="247650"/>
+            </a:xfrm>
+            <a:prstGeom prst="rect">
+              <a:avLst/>
+            </a:prstGeom>
+            <a:noFill/>
+            <a:ln>
+              <a:noFill/>
+            </a:ln>
+          </p:spPr>
+          <p:txBody>
+            <a:bodyPr wrap="square" lIns="0" tIns="63817" rIns="0" bIns="0" anchor="t" anchorCtr="0">
+              <a:noAutofit/>
             </a:bodyPr>
             <a:lstStyle/>
             <a:p>
               <a:pPr algn="ctr"/>
               <a:r>
-                <a:rPr lang="en-US" sz="1800" b="1" dirty="0">
+                <a:rPr lang="en-US" sz="1350" b="1" dirty="0">
                   <a:solidFill>
                     <a:srgbClr val="FFFFFF"/>
                   </a:solidFill>
@@ -14072,26 +14072,26 @@
           </p:nvSpPr>
           <p:spPr>
             <a:xfrm>
-              <a:off x="1163884" y="4759642"/>
-              <a:ext cx="3920633" cy="264033"/>
-            </a:xfrm>
-            <a:prstGeom prst="rect">
-              <a:avLst/>
-            </a:prstGeom>
-            <a:noFill/>
-            <a:ln>
-              <a:noFill/>
-            </a:ln>
-          </p:spPr>
-          <p:txBody>
-            <a:bodyPr wrap="none" lIns="0" tIns="0" rIns="0" bIns="0" anchor="t" anchorCtr="0">
-              <a:spAutoFit/>
+              <a:off x="1809750" y="4695825"/>
+              <a:ext cx="2628900" cy="266700"/>
+            </a:xfrm>
+            <a:prstGeom prst="rect">
+              <a:avLst/>
+            </a:prstGeom>
+            <a:noFill/>
+            <a:ln>
+              <a:noFill/>
+            </a:ln>
+          </p:spPr>
+          <p:txBody>
+            <a:bodyPr wrap="square" lIns="0" tIns="96203" rIns="0" bIns="0" anchor="t" anchorCtr="0">
+              <a:noAutofit/>
             </a:bodyPr>
             <a:lstStyle/>
             <a:p>
               <a:pPr algn="ctr"/>
               <a:r>
-                <a:rPr lang="en-US" sz="1350" dirty="0">
+                <a:rPr lang="en-US" sz="1050" dirty="0">
                   <a:solidFill>
                     <a:srgbClr val="FFFFFF"/>
                   </a:solidFill>
@@ -14099,7 +14099,7 @@
                   <a:ea typeface="+mn-ea"/>
                   <a:cs typeface="+mn-cs"/>
                 </a:rPr>
-                <a:t>No unique DAG or effect comes from the PAG</a:t>
+                <a:t>PAG yields no unique DAG or effect</a:t>
               </a:r>
             </a:p>
           </p:txBody>
@@ -14113,10 +14113,10 @@
         </p:nvGrpSpPr>
         <p:grpSpPr>
           <a:xfrm>
-            <a:off x="6546342" y="1664018"/>
-            <a:ext cx="5112258" cy="3365182"/>
-            <a:chOff x="6546342" y="1664018"/>
-            <a:chExt cx="5112258" cy="3365182"/>
+            <a:off x="6553200" y="1590675"/>
+            <a:ext cx="5105400" cy="3438525"/>
+            <a:chOff x="6553200" y="1590675"/>
+            <a:chExt cx="5105400" cy="3438525"/>
           </a:xfrm>
         </p:grpSpPr>
         <p:sp>
@@ -14127,20 +14127,20 @@
           </p:nvSpPr>
           <p:spPr>
             <a:xfrm>
-              <a:off x="6546342" y="1664018"/>
-              <a:ext cx="2433218" cy="264033"/>
-            </a:xfrm>
-            <a:prstGeom prst="rect">
-              <a:avLst/>
-            </a:prstGeom>
-            <a:noFill/>
-            <a:ln>
-              <a:noFill/>
-            </a:ln>
-          </p:spPr>
-          <p:txBody>
-            <a:bodyPr wrap="none" lIns="0" tIns="0" rIns="0" bIns="0" anchor="t" anchorCtr="0">
-              <a:spAutoFit/>
+              <a:off x="6553200" y="1590675"/>
+              <a:ext cx="2857500" cy="285750"/>
+            </a:xfrm>
+            <a:prstGeom prst="rect">
+              <a:avLst/>
+            </a:prstGeom>
+            <a:noFill/>
+            <a:ln>
+              <a:noFill/>
+            </a:ln>
+          </p:spPr>
+          <p:txBody>
+            <a:bodyPr wrap="square" lIns="0" tIns="73342" rIns="0" bIns="0" anchor="t" anchorCtr="0">
+              <a:noAutofit/>
             </a:bodyPr>
             <a:lstStyle/>
             <a:p>
@@ -14215,20 +14215,20 @@
           </p:nvSpPr>
           <p:spPr>
             <a:xfrm>
-              <a:off x="6848856" y="2215515"/>
-              <a:ext cx="3474709" cy="352044"/>
-            </a:xfrm>
-            <a:prstGeom prst="rect">
-              <a:avLst/>
-            </a:prstGeom>
-            <a:noFill/>
-            <a:ln>
-              <a:noFill/>
-            </a:ln>
-          </p:spPr>
-          <p:txBody>
-            <a:bodyPr wrap="none" lIns="0" tIns="0" rIns="0" bIns="0" anchor="t" anchorCtr="0">
-              <a:spAutoFit/>
+              <a:off x="6858000" y="2181225"/>
+              <a:ext cx="4476750" cy="304800"/>
+            </a:xfrm>
+            <a:prstGeom prst="rect">
+              <a:avLst/>
+            </a:prstGeom>
+            <a:noFill/>
+            <a:ln>
+              <a:noFill/>
+            </a:ln>
+          </p:spPr>
+          <p:txBody>
+            <a:bodyPr wrap="square" lIns="0" tIns="34290" rIns="0" bIns="0" anchor="t" anchorCtr="0">
+              <a:noAutofit/>
             </a:bodyPr>
             <a:lstStyle/>
             <a:p>
@@ -14255,20 +14255,20 @@
           </p:nvSpPr>
           <p:spPr>
             <a:xfrm>
-              <a:off x="6851142" y="2559368"/>
-              <a:ext cx="3995677" cy="264033"/>
-            </a:xfrm>
-            <a:prstGeom prst="rect">
-              <a:avLst/>
-            </a:prstGeom>
-            <a:noFill/>
-            <a:ln>
-              <a:noFill/>
-            </a:ln>
-          </p:spPr>
-          <p:txBody>
-            <a:bodyPr wrap="none" lIns="0" tIns="0" rIns="0" bIns="0" anchor="t" anchorCtr="0">
-              <a:spAutoFit/>
+              <a:off x="6858000" y="2505075"/>
+              <a:ext cx="4476750" cy="266700"/>
+            </a:xfrm>
+            <a:prstGeom prst="rect">
+              <a:avLst/>
+            </a:prstGeom>
+            <a:noFill/>
+            <a:ln>
+              <a:noFill/>
+            </a:ln>
+          </p:spPr>
+          <p:txBody>
+            <a:bodyPr wrap="square" lIns="0" tIns="54292" rIns="0" bIns="0" anchor="t" anchorCtr="0">
+              <a:noAutofit/>
             </a:bodyPr>
             <a:lstStyle/>
             <a:p>
@@ -14282,7 +14282,7 @@
                   <a:ea typeface="+mn-ea"/>
                   <a:cs typeface="+mn-cs"/>
                 </a:rPr>
-                <a:t>FCI and FCI+ stages traced to code and tests</a:t>
+                <a:t>FCI and FCI Plus stages traced to code and tests</a:t>
               </a:r>
             </a:p>
           </p:txBody>
@@ -14343,20 +14343,20 @@
           </p:nvSpPr>
           <p:spPr>
             <a:xfrm>
-              <a:off x="6848856" y="3263265"/>
-              <a:ext cx="3933027" cy="352044"/>
-            </a:xfrm>
-            <a:prstGeom prst="rect">
-              <a:avLst/>
-            </a:prstGeom>
-            <a:noFill/>
-            <a:ln>
-              <a:noFill/>
-            </a:ln>
-          </p:spPr>
-          <p:txBody>
-            <a:bodyPr wrap="none" lIns="0" tIns="0" rIns="0" bIns="0" anchor="t" anchorCtr="0">
-              <a:spAutoFit/>
+              <a:off x="6858000" y="3228975"/>
+              <a:ext cx="4476750" cy="304800"/>
+            </a:xfrm>
+            <a:prstGeom prst="rect">
+              <a:avLst/>
+            </a:prstGeom>
+            <a:noFill/>
+            <a:ln>
+              <a:noFill/>
+            </a:ln>
+          </p:spPr>
+          <p:txBody>
+            <a:bodyPr wrap="square" lIns="0" tIns="34290" rIns="0" bIns="0" anchor="t" anchorCtr="0">
+              <a:noAutofit/>
             </a:bodyPr>
             <a:lstStyle/>
             <a:p>
@@ -14383,20 +14383,20 @@
           </p:nvSpPr>
           <p:spPr>
             <a:xfrm>
-              <a:off x="6851142" y="3607118"/>
-              <a:ext cx="4054450" cy="264033"/>
-            </a:xfrm>
-            <a:prstGeom prst="rect">
-              <a:avLst/>
-            </a:prstGeom>
-            <a:noFill/>
-            <a:ln>
-              <a:noFill/>
-            </a:ln>
-          </p:spPr>
-          <p:txBody>
-            <a:bodyPr wrap="none" lIns="0" tIns="0" rIns="0" bIns="0" anchor="t" anchorCtr="0">
-              <a:spAutoFit/>
+              <a:off x="6858000" y="3552825"/>
+              <a:ext cx="4476750" cy="266700"/>
+            </a:xfrm>
+            <a:prstGeom prst="rect">
+              <a:avLst/>
+            </a:prstGeom>
+            <a:noFill/>
+            <a:ln>
+              <a:noFill/>
+            </a:ln>
+          </p:spPr>
+          <p:txBody>
+            <a:bodyPr wrap="square" lIns="0" tIns="54292" rIns="0" bIns="0" anchor="t" anchorCtr="0">
+              <a:noAutofit/>
             </a:bodyPr>
             <a:lstStyle/>
             <a:p>
@@ -14471,20 +14471,20 @@
           </p:nvSpPr>
           <p:spPr>
             <a:xfrm>
-              <a:off x="6848856" y="4311015"/>
-              <a:ext cx="4644324" cy="352044"/>
-            </a:xfrm>
-            <a:prstGeom prst="rect">
-              <a:avLst/>
-            </a:prstGeom>
-            <a:noFill/>
-            <a:ln>
-              <a:noFill/>
-            </a:ln>
-          </p:spPr>
-          <p:txBody>
-            <a:bodyPr wrap="none" lIns="0" tIns="0" rIns="0" bIns="0" anchor="t" anchorCtr="0">
-              <a:spAutoFit/>
+              <a:off x="6858000" y="4276725"/>
+              <a:ext cx="4476750" cy="304800"/>
+            </a:xfrm>
+            <a:prstGeom prst="rect">
+              <a:avLst/>
+            </a:prstGeom>
+            <a:noFill/>
+            <a:ln>
+              <a:noFill/>
+            </a:ln>
+          </p:spPr>
+          <p:txBody>
+            <a:bodyPr wrap="square" lIns="0" tIns="34290" rIns="0" bIns="0" anchor="t" anchorCtr="0">
+              <a:noAutofit/>
             </a:bodyPr>
             <a:lstStyle/>
             <a:p>
@@ -14511,20 +14511,20 @@
           </p:nvSpPr>
           <p:spPr>
             <a:xfrm>
-              <a:off x="6851142" y="4654868"/>
-              <a:ext cx="4120881" cy="264033"/>
-            </a:xfrm>
-            <a:prstGeom prst="rect">
-              <a:avLst/>
-            </a:prstGeom>
-            <a:noFill/>
-            <a:ln>
-              <a:noFill/>
-            </a:ln>
-          </p:spPr>
-          <p:txBody>
-            <a:bodyPr wrap="none" lIns="0" tIns="0" rIns="0" bIns="0" anchor="t" anchorCtr="0">
-              <a:spAutoFit/>
+              <a:off x="6858000" y="4600575"/>
+              <a:ext cx="4476750" cy="266700"/>
+            </a:xfrm>
+            <a:prstGeom prst="rect">
+              <a:avLst/>
+            </a:prstGeom>
+            <a:noFill/>
+            <a:ln>
+              <a:noFill/>
+            </a:ln>
+          </p:spPr>
+          <p:txBody>
+            <a:bodyPr wrap="square" lIns="0" tIns="54292" rIns="0" bIns="0" anchor="t" anchorCtr="0">
+              <a:noAutofit/>
             </a:bodyPr>
             <a:lstStyle/>
             <a:p>
@@ -14552,10 +14552,10 @@
         </p:nvGrpSpPr>
         <p:grpSpPr>
           <a:xfrm>
-            <a:off x="526542" y="5562600"/>
-            <a:ext cx="11132058" cy="474345"/>
-            <a:chOff x="526542" y="5562600"/>
-            <a:chExt cx="11132058" cy="474345"/>
+            <a:off x="533400" y="5562600"/>
+            <a:ext cx="11125200" cy="419100"/>
+            <a:chOff x="533400" y="5562600"/>
+            <a:chExt cx="11125200" cy="419100"/>
           </a:xfrm>
         </p:grpSpPr>
         <p:sp>
@@ -14602,20 +14602,20 @@
           </p:nvSpPr>
           <p:spPr>
             <a:xfrm>
-              <a:off x="526542" y="5759768"/>
-              <a:ext cx="1566230" cy="264033"/>
-            </a:xfrm>
-            <a:prstGeom prst="rect">
-              <a:avLst/>
-            </a:prstGeom>
-            <a:noFill/>
-            <a:ln>
-              <a:noFill/>
-            </a:ln>
-          </p:spPr>
-          <p:txBody>
-            <a:bodyPr wrap="none" lIns="0" tIns="0" rIns="0" bIns="0" anchor="t" anchorCtr="0">
-              <a:spAutoFit/>
+              <a:off x="533400" y="5676900"/>
+              <a:ext cx="1524000" cy="285750"/>
+            </a:xfrm>
+            <a:prstGeom prst="rect">
+              <a:avLst/>
+            </a:prstGeom>
+            <a:noFill/>
+            <a:ln>
+              <a:noFill/>
+            </a:ln>
+          </p:spPr>
+          <p:txBody>
+            <a:bodyPr wrap="square" lIns="0" tIns="82868" rIns="0" bIns="0" anchor="t" anchorCtr="0">
+              <a:noAutofit/>
             </a:bodyPr>
             <a:lstStyle/>
             <a:p>
@@ -14642,20 +14642,20 @@
           </p:nvSpPr>
           <p:spPr>
             <a:xfrm>
-              <a:off x="2202180" y="5743575"/>
-              <a:ext cx="8738949" cy="293370"/>
-            </a:xfrm>
-            <a:prstGeom prst="rect">
-              <a:avLst/>
-            </a:prstGeom>
-            <a:noFill/>
-            <a:ln>
-              <a:noFill/>
-            </a:ln>
-          </p:spPr>
-          <p:txBody>
-            <a:bodyPr wrap="none" lIns="0" tIns="0" rIns="0" bIns="0" anchor="t" anchorCtr="0">
-              <a:spAutoFit/>
+              <a:off x="2209800" y="5657850"/>
+              <a:ext cx="9239250" cy="323850"/>
+            </a:xfrm>
+            <a:prstGeom prst="rect">
+              <a:avLst/>
+            </a:prstGeom>
+            <a:noFill/>
+            <a:ln>
+              <a:noFill/>
+            </a:ln>
+          </p:spPr>
+          <p:txBody>
+            <a:bodyPr wrap="square" lIns="0" tIns="85725" rIns="0" bIns="0" anchor="t" anchorCtr="0">
+              <a:noAutofit/>
             </a:bodyPr>
             <a:lstStyle/>
             <a:p>
@@ -16579,10 +16579,10 @@
         </p:nvGrpSpPr>
         <p:grpSpPr>
           <a:xfrm>
-            <a:off x="1143000" y="1428750"/>
-            <a:ext cx="10289406" cy="4226243"/>
-            <a:chOff x="1143000" y="1428750"/>
-            <a:chExt cx="10289406" cy="4226243"/>
+            <a:off x="1143000" y="1419225"/>
+            <a:ext cx="9953625" cy="4162425"/>
+            <a:chOff x="1143000" y="1419225"/>
+            <a:chExt cx="9953625" cy="4162425"/>
           </a:xfrm>
         </p:grpSpPr>
         <p:sp>
@@ -16691,20 +16691,20 @@
           </p:nvSpPr>
           <p:spPr>
             <a:xfrm>
-              <a:off x="1945767" y="1492568"/>
-              <a:ext cx="719404" cy="264033"/>
-            </a:xfrm>
-            <a:prstGeom prst="rect">
-              <a:avLst/>
-            </a:prstGeom>
-            <a:noFill/>
-            <a:ln>
-              <a:noFill/>
-            </a:ln>
-          </p:spPr>
-          <p:txBody>
-            <a:bodyPr wrap="none" lIns="0" tIns="0" rIns="0" bIns="0" anchor="t" anchorCtr="0">
-              <a:spAutoFit/>
+              <a:off x="1952625" y="1419225"/>
+              <a:ext cx="1809750" cy="266700"/>
+            </a:xfrm>
+            <a:prstGeom prst="rect">
+              <a:avLst/>
+            </a:prstGeom>
+            <a:noFill/>
+            <a:ln>
+              <a:noFill/>
+            </a:ln>
+          </p:spPr>
+          <p:txBody>
+            <a:bodyPr wrap="square" lIns="0" tIns="73342" rIns="0" bIns="0" anchor="t" anchorCtr="0">
+              <a:noAutofit/>
             </a:bodyPr>
             <a:lstStyle/>
             <a:p>
@@ -16731,20 +16731,20 @@
           </p:nvSpPr>
           <p:spPr>
             <a:xfrm>
-              <a:off x="1941195" y="1709738"/>
-              <a:ext cx="9431791" cy="440055"/>
-            </a:xfrm>
-            <a:prstGeom prst="rect">
-              <a:avLst/>
-            </a:prstGeom>
-            <a:noFill/>
-            <a:ln>
-              <a:noFill/>
-            </a:ln>
-          </p:spPr>
-          <p:txBody>
-            <a:bodyPr wrap="none" lIns="0" tIns="0" rIns="0" bIns="0" anchor="t" anchorCtr="0">
-              <a:spAutoFit/>
+              <a:off x="1952625" y="1695450"/>
+              <a:ext cx="9144000" cy="381000"/>
+            </a:xfrm>
+            <a:prstGeom prst="rect">
+              <a:avLst/>
+            </a:prstGeom>
+            <a:noFill/>
+            <a:ln>
+              <a:noFill/>
+            </a:ln>
+          </p:spPr>
+          <p:txBody>
+            <a:bodyPr wrap="square" lIns="0" tIns="14288" rIns="0" bIns="0" anchor="t" anchorCtr="0">
+              <a:noAutofit/>
             </a:bodyPr>
             <a:lstStyle/>
             <a:p>
@@ -16833,20 +16833,20 @@
           </p:nvSpPr>
           <p:spPr>
             <a:xfrm>
-              <a:off x="1945767" y="2368868"/>
-              <a:ext cx="1243630" cy="264033"/>
-            </a:xfrm>
-            <a:prstGeom prst="rect">
-              <a:avLst/>
-            </a:prstGeom>
-            <a:noFill/>
-            <a:ln>
-              <a:noFill/>
-            </a:ln>
-          </p:spPr>
-          <p:txBody>
-            <a:bodyPr wrap="none" lIns="0" tIns="0" rIns="0" bIns="0" anchor="t" anchorCtr="0">
-              <a:spAutoFit/>
+              <a:off x="1952625" y="2295525"/>
+              <a:ext cx="1809750" cy="266700"/>
+            </a:xfrm>
+            <a:prstGeom prst="rect">
+              <a:avLst/>
+            </a:prstGeom>
+            <a:noFill/>
+            <a:ln>
+              <a:noFill/>
+            </a:ln>
+          </p:spPr>
+          <p:txBody>
+            <a:bodyPr wrap="square" lIns="0" tIns="73342" rIns="0" bIns="0" anchor="t" anchorCtr="0">
+              <a:noAutofit/>
             </a:bodyPr>
             <a:lstStyle/>
             <a:p>
@@ -16873,20 +16873,20 @@
           </p:nvSpPr>
           <p:spPr>
             <a:xfrm>
-              <a:off x="1941195" y="2586038"/>
-              <a:ext cx="8000755" cy="440055"/>
-            </a:xfrm>
-            <a:prstGeom prst="rect">
-              <a:avLst/>
-            </a:prstGeom>
-            <a:noFill/>
-            <a:ln>
-              <a:noFill/>
-            </a:ln>
-          </p:spPr>
-          <p:txBody>
-            <a:bodyPr wrap="none" lIns="0" tIns="0" rIns="0" bIns="0" anchor="t" anchorCtr="0">
-              <a:spAutoFit/>
+              <a:off x="1952625" y="2571750"/>
+              <a:ext cx="9144000" cy="381000"/>
+            </a:xfrm>
+            <a:prstGeom prst="rect">
+              <a:avLst/>
+            </a:prstGeom>
+            <a:noFill/>
+            <a:ln>
+              <a:noFill/>
+            </a:ln>
+          </p:spPr>
+          <p:txBody>
+            <a:bodyPr wrap="square" lIns="0" tIns="14288" rIns="0" bIns="0" anchor="t" anchorCtr="0">
+              <a:noAutofit/>
             </a:bodyPr>
             <a:lstStyle/>
             <a:p>
@@ -16975,20 +16975,20 @@
           </p:nvSpPr>
           <p:spPr>
             <a:xfrm>
-              <a:off x="1945767" y="3245168"/>
-              <a:ext cx="1263792" cy="264033"/>
-            </a:xfrm>
-            <a:prstGeom prst="rect">
-              <a:avLst/>
-            </a:prstGeom>
-            <a:noFill/>
-            <a:ln>
-              <a:noFill/>
-            </a:ln>
-          </p:spPr>
-          <p:txBody>
-            <a:bodyPr wrap="none" lIns="0" tIns="0" rIns="0" bIns="0" anchor="t" anchorCtr="0">
-              <a:spAutoFit/>
+              <a:off x="1952625" y="3171825"/>
+              <a:ext cx="1809750" cy="266700"/>
+            </a:xfrm>
+            <a:prstGeom prst="rect">
+              <a:avLst/>
+            </a:prstGeom>
+            <a:noFill/>
+            <a:ln>
+              <a:noFill/>
+            </a:ln>
+          </p:spPr>
+          <p:txBody>
+            <a:bodyPr wrap="square" lIns="0" tIns="73342" rIns="0" bIns="0" anchor="t" anchorCtr="0">
+              <a:noAutofit/>
             </a:bodyPr>
             <a:lstStyle/>
             <a:p>
@@ -17015,20 +17015,20 @@
           </p:nvSpPr>
           <p:spPr>
             <a:xfrm>
-              <a:off x="1941195" y="3462338"/>
-              <a:ext cx="7460449" cy="440055"/>
-            </a:xfrm>
-            <a:prstGeom prst="rect">
-              <a:avLst/>
-            </a:prstGeom>
-            <a:noFill/>
-            <a:ln>
-              <a:noFill/>
-            </a:ln>
-          </p:spPr>
-          <p:txBody>
-            <a:bodyPr wrap="none" lIns="0" tIns="0" rIns="0" bIns="0" anchor="t" anchorCtr="0">
-              <a:spAutoFit/>
+              <a:off x="1952625" y="3448050"/>
+              <a:ext cx="9144000" cy="381000"/>
+            </a:xfrm>
+            <a:prstGeom prst="rect">
+              <a:avLst/>
+            </a:prstGeom>
+            <a:noFill/>
+            <a:ln>
+              <a:noFill/>
+            </a:ln>
+          </p:spPr>
+          <p:txBody>
+            <a:bodyPr wrap="square" lIns="0" tIns="14288" rIns="0" bIns="0" anchor="t" anchorCtr="0">
+              <a:noAutofit/>
             </a:bodyPr>
             <a:lstStyle/>
             <a:p>
@@ -17117,20 +17117,20 @@
           </p:nvSpPr>
           <p:spPr>
             <a:xfrm>
-              <a:off x="1945767" y="4121468"/>
-              <a:ext cx="981517" cy="264033"/>
-            </a:xfrm>
-            <a:prstGeom prst="rect">
-              <a:avLst/>
-            </a:prstGeom>
-            <a:noFill/>
-            <a:ln>
-              <a:noFill/>
-            </a:ln>
-          </p:spPr>
-          <p:txBody>
-            <a:bodyPr wrap="none" lIns="0" tIns="0" rIns="0" bIns="0" anchor="t" anchorCtr="0">
-              <a:spAutoFit/>
+              <a:off x="1952625" y="4048125"/>
+              <a:ext cx="1809750" cy="266700"/>
+            </a:xfrm>
+            <a:prstGeom prst="rect">
+              <a:avLst/>
+            </a:prstGeom>
+            <a:noFill/>
+            <a:ln>
+              <a:noFill/>
+            </a:ln>
+          </p:spPr>
+          <p:txBody>
+            <a:bodyPr wrap="square" lIns="0" tIns="73342" rIns="0" bIns="0" anchor="t" anchorCtr="0">
+              <a:noAutofit/>
             </a:bodyPr>
             <a:lstStyle/>
             <a:p>
@@ -17157,20 +17157,20 @@
           </p:nvSpPr>
           <p:spPr>
             <a:xfrm>
-              <a:off x="1941195" y="4338638"/>
-              <a:ext cx="8159229" cy="440055"/>
-            </a:xfrm>
-            <a:prstGeom prst="rect">
-              <a:avLst/>
-            </a:prstGeom>
-            <a:noFill/>
-            <a:ln>
-              <a:noFill/>
-            </a:ln>
-          </p:spPr>
-          <p:txBody>
-            <a:bodyPr wrap="none" lIns="0" tIns="0" rIns="0" bIns="0" anchor="t" anchorCtr="0">
-              <a:spAutoFit/>
+              <a:off x="1952625" y="4324350"/>
+              <a:ext cx="9144000" cy="381000"/>
+            </a:xfrm>
+            <a:prstGeom prst="rect">
+              <a:avLst/>
+            </a:prstGeom>
+            <a:noFill/>
+            <a:ln>
+              <a:noFill/>
+            </a:ln>
+          </p:spPr>
+          <p:txBody>
+            <a:bodyPr wrap="square" lIns="0" tIns="14288" rIns="0" bIns="0" anchor="t" anchorCtr="0">
+              <a:noAutofit/>
             </a:bodyPr>
             <a:lstStyle/>
             <a:p>
@@ -17259,20 +17259,20 @@
           </p:nvSpPr>
           <p:spPr>
             <a:xfrm>
-              <a:off x="1945767" y="4997768"/>
-              <a:ext cx="1173061" cy="264033"/>
-            </a:xfrm>
-            <a:prstGeom prst="rect">
-              <a:avLst/>
-            </a:prstGeom>
-            <a:noFill/>
-            <a:ln>
-              <a:noFill/>
-            </a:ln>
-          </p:spPr>
-          <p:txBody>
-            <a:bodyPr wrap="none" lIns="0" tIns="0" rIns="0" bIns="0" anchor="t" anchorCtr="0">
-              <a:spAutoFit/>
+              <a:off x="1952625" y="4924425"/>
+              <a:ext cx="1809750" cy="266700"/>
+            </a:xfrm>
+            <a:prstGeom prst="rect">
+              <a:avLst/>
+            </a:prstGeom>
+            <a:noFill/>
+            <a:ln>
+              <a:noFill/>
+            </a:ln>
+          </p:spPr>
+          <p:txBody>
+            <a:bodyPr wrap="square" lIns="0" tIns="73343" rIns="0" bIns="0" anchor="t" anchorCtr="0">
+              <a:noAutofit/>
             </a:bodyPr>
             <a:lstStyle/>
             <a:p>
@@ -17299,20 +17299,20 @@
           </p:nvSpPr>
           <p:spPr>
             <a:xfrm>
-              <a:off x="1941195" y="5214938"/>
-              <a:ext cx="9491211" cy="440055"/>
-            </a:xfrm>
-            <a:prstGeom prst="rect">
-              <a:avLst/>
-            </a:prstGeom>
-            <a:noFill/>
-            <a:ln>
-              <a:noFill/>
-            </a:ln>
-          </p:spPr>
-          <p:txBody>
-            <a:bodyPr wrap="none" lIns="0" tIns="0" rIns="0" bIns="0" anchor="t" anchorCtr="0">
-              <a:spAutoFit/>
+              <a:off x="1952625" y="5200650"/>
+              <a:ext cx="9144000" cy="381000"/>
+            </a:xfrm>
+            <a:prstGeom prst="rect">
+              <a:avLst/>
+            </a:prstGeom>
+            <a:noFill/>
+            <a:ln>
+              <a:noFill/>
+            </a:ln>
+          </p:spPr>
+          <p:txBody>
+            <a:bodyPr wrap="square" lIns="0" tIns="14288" rIns="0" bIns="0" anchor="t" anchorCtr="0">
+              <a:noAutofit/>
             </a:bodyPr>
             <a:lstStyle/>
             <a:p>
@@ -18324,26 +18324,26 @@
           </p:nvSpPr>
           <p:spPr>
             <a:xfrm>
-              <a:off x="6092274" y="2167890"/>
-              <a:ext cx="1893402" cy="352044"/>
-            </a:xfrm>
-            <a:prstGeom prst="rect">
-              <a:avLst/>
-            </a:prstGeom>
-            <a:noFill/>
-            <a:ln>
-              <a:noFill/>
-            </a:ln>
-          </p:spPr>
-          <p:txBody>
-            <a:bodyPr wrap="none" lIns="0" tIns="0" rIns="0" bIns="0" anchor="t" anchorCtr="0">
-              <a:spAutoFit/>
+              <a:off x="6257925" y="2143125"/>
+              <a:ext cx="1562100" cy="266700"/>
+            </a:xfrm>
+            <a:prstGeom prst="rect">
+              <a:avLst/>
+            </a:prstGeom>
+            <a:noFill/>
+            <a:ln>
+              <a:noFill/>
+            </a:ln>
+          </p:spPr>
+          <p:txBody>
+            <a:bodyPr wrap="square" lIns="0" tIns="73342" rIns="0" bIns="0" anchor="t" anchorCtr="0">
+              <a:noAutofit/>
             </a:bodyPr>
             <a:lstStyle/>
             <a:p>
               <a:pPr algn="ctr"/>
               <a:r>
-                <a:rPr lang="en-US" sz="1800" b="1" dirty="0">
+                <a:rPr lang="en-US" sz="1350" b="1" dirty="0">
                   <a:solidFill>
                     <a:schemeClr val="accent1"/>
                   </a:solidFill>
@@ -18364,26 +18364,26 @@
           </p:nvSpPr>
           <p:spPr>
             <a:xfrm>
-              <a:off x="6291979" y="2444115"/>
-              <a:ext cx="1493992" cy="352044"/>
-            </a:xfrm>
-            <a:prstGeom prst="rect">
-              <a:avLst/>
-            </a:prstGeom>
-            <a:noFill/>
-            <a:ln>
-              <a:noFill/>
-            </a:ln>
-          </p:spPr>
-          <p:txBody>
-            <a:bodyPr wrap="none" lIns="0" tIns="0" rIns="0" bIns="0" anchor="t" anchorCtr="0">
-              <a:spAutoFit/>
+              <a:off x="6257925" y="2438400"/>
+              <a:ext cx="1562100" cy="266700"/>
+            </a:xfrm>
+            <a:prstGeom prst="rect">
+              <a:avLst/>
+            </a:prstGeom>
+            <a:noFill/>
+            <a:ln>
+              <a:noFill/>
+            </a:ln>
+          </p:spPr>
+          <p:txBody>
+            <a:bodyPr wrap="square" lIns="0" tIns="65246" rIns="0" bIns="0" anchor="t" anchorCtr="0">
+              <a:noAutofit/>
             </a:bodyPr>
             <a:lstStyle/>
             <a:p>
               <a:pPr algn="ctr"/>
               <a:r>
-                <a:rPr lang="en-US" sz="1800" b="1" dirty="0">
+                <a:rPr lang="en-US" sz="1420" b="1" dirty="0">
                   <a:solidFill>
                     <a:schemeClr val="accent1"/>
                   </a:solidFill>
@@ -19434,10 +19434,10 @@
         </p:nvGrpSpPr>
         <p:grpSpPr>
           <a:xfrm>
-            <a:off x="517398" y="364808"/>
-            <a:ext cx="11148060" cy="654367"/>
-            <a:chOff x="517398" y="364808"/>
-            <a:chExt cx="11148060" cy="654367"/>
+            <a:off x="518160" y="381000"/>
+            <a:ext cx="11147298" cy="638175"/>
+            <a:chOff x="518160" y="381000"/>
+            <a:chExt cx="11147298" cy="638175"/>
           </a:xfrm>
         </p:grpSpPr>
         <p:sp>
@@ -19448,8 +19448,8 @@
           </p:nvSpPr>
           <p:spPr>
             <a:xfrm>
-              <a:off x="517398" y="364808"/>
-              <a:ext cx="10385594" cy="616077"/>
+              <a:off x="518160" y="381000"/>
+              <a:ext cx="10696633" cy="586740"/>
             </a:xfrm>
             <a:prstGeom prst="rect">
               <a:avLst/>
@@ -19467,7 +19467,7 @@
             <a:p>
               <a:pPr algn="l"/>
               <a:r>
-                <a:rPr lang="en-US" sz="3150" b="1" dirty="0">
+                <a:rPr lang="en-US" sz="3000" b="1" dirty="0">
                   <a:solidFill>
                     <a:schemeClr val="accent1"/>
                   </a:solidFill>
@@ -19475,7 +19475,7 @@
                   <a:ea typeface="+mj-ea"/>
                   <a:cs typeface="+mj-cs"/>
                 </a:rPr>
-                <a:t>FCI+ Uses a Sparse Logical Characterization</a:t>
+                <a:t>FCI Plus Uses a Sparse Logical Characterization</a:t>
               </a:r>
             </a:p>
           </p:txBody>
@@ -20471,10 +20471,10 @@
         </p:nvGrpSpPr>
         <p:grpSpPr>
           <a:xfrm>
-            <a:off x="526542" y="5416868"/>
-            <a:ext cx="8239887" cy="360616"/>
-            <a:chOff x="526542" y="5416868"/>
-            <a:chExt cx="8239887" cy="360616"/>
+            <a:off x="526542" y="5353050"/>
+            <a:ext cx="8239887" cy="398145"/>
+            <a:chOff x="526542" y="5353050"/>
+            <a:chExt cx="8239887" cy="398145"/>
           </a:xfrm>
         </p:grpSpPr>
         <p:sp>
@@ -20525,26 +20525,26 @@
           </p:nvSpPr>
           <p:spPr>
             <a:xfrm>
-              <a:off x="2257806" y="5425440"/>
-              <a:ext cx="1537198" cy="352044"/>
-            </a:xfrm>
-            <a:prstGeom prst="rect">
-              <a:avLst/>
-            </a:prstGeom>
-            <a:noFill/>
-            <a:ln>
-              <a:noFill/>
-            </a:ln>
-          </p:spPr>
-          <p:txBody>
-            <a:bodyPr wrap="none" lIns="0" tIns="0" rIns="0" bIns="0" anchor="t" anchorCtr="0">
-              <a:spAutoFit/>
+              <a:off x="2266950" y="5353050"/>
+              <a:ext cx="2000250" cy="342900"/>
+            </a:xfrm>
+            <a:prstGeom prst="rect">
+              <a:avLst/>
+            </a:prstGeom>
+            <a:noFill/>
+            <a:ln>
+              <a:noFill/>
+            </a:ln>
+          </p:spPr>
+          <p:txBody>
+            <a:bodyPr wrap="square" lIns="0" tIns="88582" rIns="0" bIns="0" anchor="t" anchorCtr="0">
+              <a:noAutofit/>
             </a:bodyPr>
             <a:lstStyle/>
             <a:p>
               <a:pPr algn="l"/>
               <a:r>
-                <a:rPr lang="en-US" sz="1800" b="1" dirty="0">
+                <a:rPr lang="en-US" sz="1650" b="1" dirty="0">
                   <a:solidFill>
                     <a:schemeClr val="accent3"/>
                   </a:solidFill>
@@ -20606,10 +20606,10 @@
         </p:nvGrpSpPr>
         <p:grpSpPr>
           <a:xfrm>
-            <a:off x="8455411" y="1333500"/>
-            <a:ext cx="3448804" cy="3867150"/>
-            <a:chOff x="8455411" y="1333500"/>
-            <a:chExt cx="3448804" cy="3867150"/>
+            <a:off x="8477250" y="1333500"/>
+            <a:ext cx="3426965" cy="3867150"/>
+            <a:chOff x="8477250" y="1333500"/>
+            <a:chExt cx="3426965" cy="3867150"/>
           </a:xfrm>
         </p:grpSpPr>
         <p:sp>
@@ -20684,34 +20684,34 @@
           </p:nvSpPr>
           <p:spPr>
             <a:xfrm>
-              <a:off x="8455411" y="2182178"/>
-              <a:ext cx="3225028" cy="498729"/>
-            </a:xfrm>
-            <a:prstGeom prst="rect">
-              <a:avLst/>
-            </a:prstGeom>
-            <a:noFill/>
-            <a:ln>
-              <a:noFill/>
-            </a:ln>
-          </p:spPr>
-          <p:txBody>
-            <a:bodyPr wrap="none" lIns="0" tIns="0" rIns="0" bIns="0" anchor="t" anchorCtr="0">
-              <a:spAutoFit/>
+              <a:off x="8763000" y="2095500"/>
+              <a:ext cx="2609850" cy="552450"/>
+            </a:xfrm>
+            <a:prstGeom prst="rect">
+              <a:avLst/>
+            </a:prstGeom>
+            <a:noFill/>
+            <a:ln>
+              <a:noFill/>
+            </a:ln>
+          </p:spPr>
+          <p:txBody>
+            <a:bodyPr wrap="square" lIns="0" tIns="119062" rIns="0" bIns="0" anchor="t" anchorCtr="0">
+              <a:noAutofit/>
             </a:bodyPr>
             <a:lstStyle/>
             <a:p>
               <a:pPr algn="ctr"/>
               <a:r>
-                <a:rPr lang="en-US" sz="2550" b="1" dirty="0">
+                <a:rPr lang="en-US" sz="2250" b="1" dirty="0">
                   <a:solidFill>
                     <a:srgbClr val="FFFFFF"/>
                   </a:solidFill>
-                  <a:latin typeface="+mj-lt"/>
-                  <a:ea typeface="+mj-ea"/>
-                  <a:cs typeface="+mj-cs"/>
-                </a:rPr>
-                <a:t>O(N^(2(k+2)))</a:t>
+                  <a:latin typeface="+mn-lt"/>
+                  <a:ea typeface="+mn-ea"/>
+                  <a:cs typeface="+mn-cs"/>
+                </a:rPr>
+                <a:t>O(N²ᵏ⁺⁴)</a:t>
               </a:r>
             </a:p>
           </p:txBody>
@@ -21231,8 +21231,8 @@
           </p:nvSpPr>
           <p:spPr>
             <a:xfrm>
-              <a:off x="9280246" y="844868"/>
-              <a:ext cx="2385212" cy="264033"/>
+              <a:off x="10480396" y="844868"/>
+              <a:ext cx="1185062" cy="264033"/>
             </a:xfrm>
             <a:prstGeom prst="rect">
               <a:avLst/>
@@ -21258,7 +21258,7 @@
                   <a:ea typeface="Consolas"/>
                   <a:cs typeface="Consolas"/>
                 </a:rPr>
-                <a:t>SOURCE → CODE → EVIDENCE</a:t>
+                <a:t>TRACEABILITY</a:t>
               </a:r>
             </a:p>
           </p:txBody>
@@ -21372,20 +21372,20 @@
           </p:nvSpPr>
           <p:spPr>
             <a:xfrm>
-              <a:off x="812292" y="1483042"/>
-              <a:ext cx="1596474" cy="264033"/>
-            </a:xfrm>
-            <a:prstGeom prst="rect">
-              <a:avLst/>
-            </a:prstGeom>
-            <a:noFill/>
-            <a:ln>
-              <a:noFill/>
-            </a:ln>
-          </p:spPr>
-          <p:txBody>
-            <a:bodyPr wrap="none" lIns="0" tIns="0" rIns="0" bIns="0" anchor="t" anchorCtr="0">
-              <a:spAutoFit/>
+              <a:off x="819150" y="1409700"/>
+              <a:ext cx="2190750" cy="266700"/>
+            </a:xfrm>
+            <a:prstGeom prst="rect">
+              <a:avLst/>
+            </a:prstGeom>
+            <a:noFill/>
+            <a:ln>
+              <a:noFill/>
+            </a:ln>
+          </p:spPr>
+          <p:txBody>
+            <a:bodyPr wrap="square" lIns="0" tIns="73342" rIns="0" bIns="0" anchor="t" anchorCtr="0">
+              <a:noAutofit/>
             </a:bodyPr>
             <a:lstStyle/>
             <a:p>
@@ -21399,7 +21399,7 @@
                   <a:ea typeface="+mn-ea"/>
                   <a:cs typeface="+mn-cs"/>
                 </a:rPr>
-                <a:t>SOURCE CONCEPT</a:t>
+                <a:t>SOURCE</a:t>
               </a:r>
             </a:p>
           </p:txBody>
@@ -21412,20 +21412,20 @@
           </p:nvSpPr>
           <p:spPr>
             <a:xfrm>
-              <a:off x="3574542" y="1483042"/>
-              <a:ext cx="2574356" cy="264033"/>
-            </a:xfrm>
-            <a:prstGeom prst="rect">
-              <a:avLst/>
-            </a:prstGeom>
-            <a:noFill/>
-            <a:ln>
-              <a:noFill/>
-            </a:ln>
-          </p:spPr>
-          <p:txBody>
-            <a:bodyPr wrap="none" lIns="0" tIns="0" rIns="0" bIns="0" anchor="t" anchorCtr="0">
-              <a:spAutoFit/>
+              <a:off x="3581400" y="1409700"/>
+              <a:ext cx="4000500" cy="266700"/>
+            </a:xfrm>
+            <a:prstGeom prst="rect">
+              <a:avLst/>
+            </a:prstGeom>
+            <a:noFill/>
+            <a:ln>
+              <a:noFill/>
+            </a:ln>
+          </p:spPr>
+          <p:txBody>
+            <a:bodyPr wrap="square" lIns="0" tIns="73342" rIns="0" bIns="0" anchor="t" anchorCtr="0">
+              <a:noAutofit/>
             </a:bodyPr>
             <a:lstStyle/>
             <a:p>
@@ -21452,20 +21452,20 @@
           </p:nvSpPr>
           <p:spPr>
             <a:xfrm>
-              <a:off x="8375142" y="1483042"/>
-              <a:ext cx="2090456" cy="264033"/>
-            </a:xfrm>
-            <a:prstGeom prst="rect">
-              <a:avLst/>
-            </a:prstGeom>
-            <a:noFill/>
-            <a:ln>
-              <a:noFill/>
-            </a:ln>
-          </p:spPr>
-          <p:txBody>
-            <a:bodyPr wrap="none" lIns="0" tIns="0" rIns="0" bIns="0" anchor="t" anchorCtr="0">
-              <a:spAutoFit/>
+              <a:off x="8382000" y="1409700"/>
+              <a:ext cx="2952750" cy="266700"/>
+            </a:xfrm>
+            <a:prstGeom prst="rect">
+              <a:avLst/>
+            </a:prstGeom>
+            <a:noFill/>
+            <a:ln>
+              <a:noFill/>
+            </a:ln>
+          </p:spPr>
+          <p:txBody>
+            <a:bodyPr wrap="square" lIns="0" tIns="73342" rIns="0" bIns="0" anchor="t" anchorCtr="0">
+              <a:noAutofit/>
             </a:bodyPr>
             <a:lstStyle/>
             <a:p>
@@ -22085,7 +22085,7 @@
           <p:spPr>
             <a:xfrm>
               <a:off x="810006" y="3091815"/>
-              <a:ext cx="1680168" cy="352044"/>
+              <a:ext cx="2118070" cy="352044"/>
             </a:xfrm>
             <a:prstGeom prst="rect">
               <a:avLst/>
@@ -22111,7 +22111,7 @@
                   <a:ea typeface="+mn-ea"/>
                   <a:cs typeface="+mn-cs"/>
                 </a:rPr>
-                <a:t>Claassen FCI+</a:t>
+                <a:t>Claassen FCI Plus</a:t>
               </a:r>
             </a:p>
           </p:txBody>
@@ -23330,7 +23330,7 @@
           <p:spPr>
             <a:xfrm>
               <a:off x="526542" y="1549718"/>
-              <a:ext cx="1848505" cy="264033"/>
+              <a:ext cx="2241674" cy="264033"/>
             </a:xfrm>
             <a:prstGeom prst="rect">
               <a:avLst/>
@@ -23356,7 +23356,7 @@
                   <a:ea typeface="+mn-ea"/>
                   <a:cs typeface="+mn-cs"/>
                 </a:rPr>
-                <a:t>PAPER FCI+ PROFILE</a:t>
+                <a:t>PAPER FCI PLUS PROFILE</a:t>
               </a:r>
             </a:p>
           </p:txBody>
@@ -25711,7 +25711,7 @@
           <p:spPr>
             <a:xfrm>
               <a:off x="8574405" y="2552700"/>
-              <a:ext cx="765734" cy="293370"/>
+              <a:ext cx="1120607" cy="293370"/>
             </a:xfrm>
             <a:prstGeom prst="rect">
               <a:avLst/>
@@ -25737,7 +25737,7 @@
                   <a:ea typeface="Consolas"/>
                   <a:cs typeface="Consolas"/>
                 </a:rPr>
-                <a:t>FCI+ 63</a:t>
+                <a:t>FCI Plus 63</a:t>
               </a:r>
             </a:p>
           </p:txBody>
@@ -27039,26 +27039,26 @@
           </p:nvSpPr>
           <p:spPr>
             <a:xfrm>
-              <a:off x="4225682" y="1540192"/>
-              <a:ext cx="406885" cy="264033"/>
-            </a:xfrm>
-            <a:prstGeom prst="rect">
-              <a:avLst/>
-            </a:prstGeom>
-            <a:noFill/>
-            <a:ln>
-              <a:noFill/>
-            </a:ln>
-          </p:spPr>
-          <p:txBody>
-            <a:bodyPr wrap="none" lIns="0" tIns="0" rIns="0" bIns="0" anchor="t" anchorCtr="0">
-              <a:spAutoFit/>
+              <a:off x="3981450" y="1457325"/>
+              <a:ext cx="895350" cy="285750"/>
+            </a:xfrm>
+            <a:prstGeom prst="rect">
+              <a:avLst/>
+            </a:prstGeom>
+            <a:noFill/>
+            <a:ln>
+              <a:noFill/>
+            </a:ln>
+          </p:spPr>
+          <p:txBody>
+            <a:bodyPr wrap="square" lIns="0" tIns="99060" rIns="0" bIns="0" anchor="t" anchorCtr="0">
+              <a:noAutofit/>
             </a:bodyPr>
             <a:lstStyle/>
             <a:p>
               <a:pPr algn="ctr"/>
               <a:r>
-                <a:rPr lang="en-US" sz="1350" b="1" dirty="0">
+                <a:rPr lang="en-US" sz="1200" b="1" dirty="0">
                   <a:solidFill>
                     <a:srgbClr val="FFFFFF"/>
                   </a:solidFill>
@@ -27066,7 +27066,7 @@
                   <a:ea typeface="+mn-ea"/>
                   <a:cs typeface="+mn-cs"/>
                 </a:rPr>
-                <a:t>FCI+</a:t>
+                <a:t>FCI Plus</a:t>
               </a:r>
             </a:p>
           </p:txBody>
@@ -27079,26 +27079,26 @@
           </p:nvSpPr>
           <p:spPr>
             <a:xfrm>
-              <a:off x="5172098" y="1540192"/>
-              <a:ext cx="800054" cy="264033"/>
-            </a:xfrm>
-            <a:prstGeom prst="rect">
-              <a:avLst/>
-            </a:prstGeom>
-            <a:noFill/>
-            <a:ln>
-              <a:noFill/>
-            </a:ln>
-          </p:spPr>
-          <p:txBody>
-            <a:bodyPr wrap="none" lIns="0" tIns="0" rIns="0" bIns="0" anchor="t" anchorCtr="0">
-              <a:spAutoFit/>
+              <a:off x="5029200" y="1457325"/>
+              <a:ext cx="1085850" cy="285750"/>
+            </a:xfrm>
+            <a:prstGeom prst="rect">
+              <a:avLst/>
+            </a:prstGeom>
+            <a:noFill/>
+            <a:ln>
+              <a:noFill/>
+            </a:ln>
+          </p:spPr>
+          <p:txBody>
+            <a:bodyPr wrap="square" lIns="0" tIns="90964" rIns="0" bIns="0" anchor="t" anchorCtr="0">
+              <a:noAutofit/>
             </a:bodyPr>
             <a:lstStyle/>
             <a:p>
               <a:pPr algn="ctr"/>
               <a:r>
-                <a:rPr lang="en-US" sz="1350" b="1" dirty="0">
+                <a:rPr lang="en-US" sz="1280" b="1" dirty="0">
                   <a:solidFill>
                     <a:srgbClr val="FFFFFF"/>
                   </a:solidFill>
@@ -27119,26 +27119,26 @@
           </p:nvSpPr>
           <p:spPr>
             <a:xfrm>
-              <a:off x="6271470" y="1540192"/>
-              <a:ext cx="1173061" cy="264033"/>
-            </a:xfrm>
-            <a:prstGeom prst="rect">
-              <a:avLst/>
-            </a:prstGeom>
-            <a:noFill/>
-            <a:ln>
-              <a:noFill/>
-            </a:ln>
-          </p:spPr>
-          <p:txBody>
-            <a:bodyPr wrap="none" lIns="0" tIns="0" rIns="0" bIns="0" anchor="t" anchorCtr="0">
-              <a:spAutoFit/>
+              <a:off x="6267450" y="1457325"/>
+              <a:ext cx="1181100" cy="285750"/>
+            </a:xfrm>
+            <a:prstGeom prst="rect">
+              <a:avLst/>
+            </a:prstGeom>
+            <a:noFill/>
+            <a:ln>
+              <a:noFill/>
+            </a:ln>
+          </p:spPr>
+          <p:txBody>
+            <a:bodyPr wrap="square" lIns="0" tIns="90964" rIns="0" bIns="0" anchor="t" anchorCtr="0">
+              <a:noAutofit/>
             </a:bodyPr>
             <a:lstStyle/>
             <a:p>
               <a:pPr algn="ctr"/>
               <a:r>
-                <a:rPr lang="en-US" sz="1350" b="1" dirty="0">
+                <a:rPr lang="en-US" sz="1280" b="1" dirty="0">
                   <a:solidFill>
                     <a:srgbClr val="FFFFFF"/>
                   </a:solidFill>
@@ -27719,20 +27719,20 @@
           </p:nvSpPr>
           <p:spPr>
             <a:xfrm>
-              <a:off x="10427117" y="2235518"/>
-              <a:ext cx="900867" cy="264033"/>
-            </a:xfrm>
-            <a:prstGeom prst="rect">
-              <a:avLst/>
-            </a:prstGeom>
-            <a:noFill/>
-            <a:ln>
-              <a:noFill/>
-            </a:ln>
-          </p:spPr>
-          <p:txBody>
-            <a:bodyPr wrap="none" lIns="0" tIns="0" rIns="0" bIns="0" anchor="t" anchorCtr="0">
-              <a:spAutoFit/>
+              <a:off x="10191750" y="2171700"/>
+              <a:ext cx="1371600" cy="285750"/>
+            </a:xfrm>
+            <a:prstGeom prst="rect">
+              <a:avLst/>
+            </a:prstGeom>
+            <a:noFill/>
+            <a:ln>
+              <a:noFill/>
+            </a:ln>
+          </p:spPr>
+          <p:txBody>
+            <a:bodyPr wrap="square" lIns="0" tIns="63817" rIns="0" bIns="0" anchor="t" anchorCtr="0">
+              <a:noAutofit/>
             </a:bodyPr>
             <a:lstStyle/>
             <a:p>
@@ -27746,7 +27746,7 @@
                   <a:ea typeface="+mn-ea"/>
                   <a:cs typeface="+mn-cs"/>
                 </a:rPr>
-                <a:t>EXECUTED</a:t>
+                <a:t>RUN</a:t>
               </a:r>
             </a:p>
           </p:txBody>
@@ -27999,20 +27999,20 @@
           </p:nvSpPr>
           <p:spPr>
             <a:xfrm>
-              <a:off x="10427117" y="3016568"/>
-              <a:ext cx="900867" cy="264033"/>
-            </a:xfrm>
-            <a:prstGeom prst="rect">
-              <a:avLst/>
-            </a:prstGeom>
-            <a:noFill/>
-            <a:ln>
-              <a:noFill/>
-            </a:ln>
-          </p:spPr>
-          <p:txBody>
-            <a:bodyPr wrap="none" lIns="0" tIns="0" rIns="0" bIns="0" anchor="t" anchorCtr="0">
-              <a:spAutoFit/>
+              <a:off x="10191750" y="2952750"/>
+              <a:ext cx="1371600" cy="285750"/>
+            </a:xfrm>
+            <a:prstGeom prst="rect">
+              <a:avLst/>
+            </a:prstGeom>
+            <a:noFill/>
+            <a:ln>
+              <a:noFill/>
+            </a:ln>
+          </p:spPr>
+          <p:txBody>
+            <a:bodyPr wrap="square" lIns="0" tIns="63817" rIns="0" bIns="0" anchor="t" anchorCtr="0">
+              <a:noAutofit/>
             </a:bodyPr>
             <a:lstStyle/>
             <a:p>
@@ -28026,7 +28026,7 @@
                   <a:ea typeface="+mn-ea"/>
                   <a:cs typeface="+mn-cs"/>
                 </a:rPr>
-                <a:t>EXECUTED</a:t>
+                <a:t>RUN</a:t>
               </a:r>
             </a:p>
           </p:txBody>
@@ -28279,20 +28279,20 @@
           </p:nvSpPr>
           <p:spPr>
             <a:xfrm>
-              <a:off x="10427117" y="3797618"/>
-              <a:ext cx="900867" cy="264033"/>
-            </a:xfrm>
-            <a:prstGeom prst="rect">
-              <a:avLst/>
-            </a:prstGeom>
-            <a:noFill/>
-            <a:ln>
-              <a:noFill/>
-            </a:ln>
-          </p:spPr>
-          <p:txBody>
-            <a:bodyPr wrap="none" lIns="0" tIns="0" rIns="0" bIns="0" anchor="t" anchorCtr="0">
-              <a:spAutoFit/>
+              <a:off x="10191750" y="3733800"/>
+              <a:ext cx="1371600" cy="285750"/>
+            </a:xfrm>
+            <a:prstGeom prst="rect">
+              <a:avLst/>
+            </a:prstGeom>
+            <a:noFill/>
+            <a:ln>
+              <a:noFill/>
+            </a:ln>
+          </p:spPr>
+          <p:txBody>
+            <a:bodyPr wrap="square" lIns="0" tIns="63817" rIns="0" bIns="0" anchor="t" anchorCtr="0">
+              <a:noAutofit/>
             </a:bodyPr>
             <a:lstStyle/>
             <a:p>
@@ -28306,7 +28306,7 @@
                   <a:ea typeface="+mn-ea"/>
                   <a:cs typeface="+mn-cs"/>
                 </a:rPr>
-                <a:t>EXECUTED</a:t>
+                <a:t>RUN</a:t>
               </a:r>
             </a:p>
           </p:txBody>
@@ -28559,26 +28559,26 @@
           </p:nvSpPr>
           <p:spPr>
             <a:xfrm>
-              <a:off x="10356548" y="4578668"/>
-              <a:ext cx="1042005" cy="264033"/>
-            </a:xfrm>
-            <a:prstGeom prst="rect">
-              <a:avLst/>
-            </a:prstGeom>
-            <a:noFill/>
-            <a:ln>
-              <a:noFill/>
-            </a:ln>
-          </p:spPr>
-          <p:txBody>
-            <a:bodyPr wrap="none" lIns="0" tIns="0" rIns="0" bIns="0" anchor="t" anchorCtr="0">
-              <a:spAutoFit/>
+              <a:off x="10191750" y="4514850"/>
+              <a:ext cx="1371600" cy="285750"/>
+            </a:xfrm>
+            <a:prstGeom prst="rect">
+              <a:avLst/>
+            </a:prstGeom>
+            <a:noFill/>
+            <a:ln>
+              <a:noFill/>
+            </a:ln>
+          </p:spPr>
+          <p:txBody>
+            <a:bodyPr wrap="square" lIns="0" tIns="71914" rIns="0" bIns="0" anchor="t" anchorCtr="0">
+              <a:noAutofit/>
             </a:bodyPr>
             <a:lstStyle/>
             <a:p>
               <a:pPr algn="ctr"/>
               <a:r>
-                <a:rPr lang="en-US" sz="1350" b="1" dirty="0">
+                <a:rPr lang="en-US" sz="1280" b="1" dirty="0">
                   <a:solidFill>
                     <a:srgbClr val="5F6875"/>
                   </a:solidFill>

</xml_diff>